<commit_message>
Add model comparison slide + roadmap slide to pitch deck (12 slides)
New slides:
- Slide 8: All Models Tested — horizontal bar chart comparing 12 model
  configs (Sentiment 52%, CNN-LSTM 52.2%, GB 52.6%, CNN-LSTM Dubey 53.8%,
  XGBoost 54.6%, GRU 56.9%, GRU+XGB agree 61.2%, Triple agree 64.5%,
  RF on-chain 66%, GB on-chain 67.4%, Target: Omole & Enke 82.4%)
- Slide 9: Where It Goes From Here — next steps (Glassnode Pro for 82%,
  CNN-LSTM architecture, expand to ETH/SOL, hourly predictions) + data
  gap analysis (42 features now vs 87 with Glassnode)

Also removed backtest details from How It Works (kept signals + sources only)

Co-Authored-By: Claude Opus 4.6 (1M context) <noreply@anthropic.com>
</commit_message>
<xml_diff>
--- a/TrueMarkets_Pitch_Deck.pptx
+++ b/TrueMarkets_Pitch_Deck.pptx
@@ -15,9 +15,11 @@
     <p:sldId id="263" r:id="rId9"/>
     <p:sldId id="264" r:id="rId10"/>
     <p:sldId id="265" r:id="rId11"/>
+    <p:sldId id="266" r:id="rId12"/>
+    <p:sldId id="267" r:id="rId13"/>
   </p:sldIdLst>
   <p:notesMasterIdLst>
-    <p:notesMasterId r:id="rId12"/>
+    <p:notesMasterId r:id="rId14"/>
   </p:notesMasterIdLst>
   <p:sldSz cx="9144000" cy="5143500"/>
   <p:notesSz cx="5143500" cy="9144000"/>
@@ -623,6 +625,182 @@
             <a:fld id="{F7021451-1387-4CA6-816F-3879F97B5CBC}" type="slidenum">
               <a:rPr lang="en-US"/>
               <a:t>10</a:t>
+            </a:fld>
+            <a:endParaRPr lang="en-US"/>
+          </a:p>
+        </p:txBody>
+      </p:sp>
+    </p:spTree>
+    <p:extLst>
+      <p:ext uri="{BB962C8B-B14F-4D97-AF65-F5344CB8AC3E}">
+        <p14:creationId xmlns:p14="http://schemas.microsoft.com/office/powerpoint/2010/main" val="1024086991"/>
+      </p:ext>
+    </p:extLst>
+  </p:cSld>
+  <p:clrMapOvr>
+    <a:masterClrMapping/>
+  </p:clrMapOvr>
+</p:notes>
+</file>
+
+<file path=ppt/notesSlides/notesSlide11.xml><?xml version="1.0" encoding="utf-8"?>
+<p:notes xmlns:a="http://schemas.openxmlformats.org/drawingml/2006/main" xmlns:r="http://schemas.openxmlformats.org/officeDocument/2006/relationships" xmlns:p="http://schemas.openxmlformats.org/presentationml/2006/main">
+  <p:cSld>
+    <p:spTree>
+      <p:nvGrpSpPr>
+        <p:cNvPr id="1" name=""/>
+        <p:cNvGrpSpPr/>
+        <p:nvPr/>
+      </p:nvGrpSpPr>
+      <p:grpSpPr>
+        <a:xfrm>
+          <a:off x="0" y="0"/>
+          <a:ext cx="0" cy="0"/>
+          <a:chOff x="0" y="0"/>
+          <a:chExt cx="0" cy="0"/>
+        </a:xfrm>
+      </p:grpSpPr>
+      <p:sp>
+        <p:nvSpPr>
+          <p:cNvPr id="2" name="Slide Image Placeholder 1"/>
+          <p:cNvSpPr>
+            <a:spLocks noGrp="1" noRot="1" noChangeAspect="1"/>
+          </p:cNvSpPr>
+          <p:nvPr>
+            <p:ph type="sldImg"/>
+          </p:nvPr>
+        </p:nvSpPr>
+        <p:spPr/>
+      </p:sp>
+      <p:sp>
+        <p:nvSpPr>
+          <p:cNvPr id="3" name="Notes Placeholder 2"/>
+          <p:cNvSpPr>
+            <a:spLocks noGrp="1"/>
+          </p:cNvSpPr>
+          <p:nvPr>
+            <p:ph type="body" idx="1"/>
+          </p:nvPr>
+        </p:nvSpPr>
+        <p:spPr/>
+        <p:txBody>
+          <a:bodyPr/>
+          <a:lstStyle/>
+          <a:p>
+            <a:r>
+              <a:rPr lang="en-US" dirty="0"/>
+              <a:t/>
+            </a:r>
+            <a:endParaRPr lang="en-US" dirty="0"/>
+          </a:p>
+        </p:txBody>
+      </p:sp>
+      <p:sp>
+        <p:nvSpPr>
+          <p:cNvPr id="4" name="Slide Number Placeholder 3"/>
+          <p:cNvSpPr>
+            <a:spLocks noGrp="1"/>
+          </p:cNvSpPr>
+          <p:nvPr>
+            <p:ph type="sldNum" sz="quarter" idx="10"/>
+          </p:nvPr>
+        </p:nvSpPr>
+        <p:spPr/>
+        <p:txBody>
+          <a:bodyPr/>
+          <a:lstStyle/>
+          <a:p>
+            <a:fld id="{F7021451-1387-4CA6-816F-3879F97B5CBC}" type="slidenum">
+              <a:rPr lang="en-US"/>
+              <a:t>11</a:t>
+            </a:fld>
+            <a:endParaRPr lang="en-US"/>
+          </a:p>
+        </p:txBody>
+      </p:sp>
+    </p:spTree>
+    <p:extLst>
+      <p:ext uri="{BB962C8B-B14F-4D97-AF65-F5344CB8AC3E}">
+        <p14:creationId xmlns:p14="http://schemas.microsoft.com/office/powerpoint/2010/main" val="1024086991"/>
+      </p:ext>
+    </p:extLst>
+  </p:cSld>
+  <p:clrMapOvr>
+    <a:masterClrMapping/>
+  </p:clrMapOvr>
+</p:notes>
+</file>
+
+<file path=ppt/notesSlides/notesSlide12.xml><?xml version="1.0" encoding="utf-8"?>
+<p:notes xmlns:a="http://schemas.openxmlformats.org/drawingml/2006/main" xmlns:r="http://schemas.openxmlformats.org/officeDocument/2006/relationships" xmlns:p="http://schemas.openxmlformats.org/presentationml/2006/main">
+  <p:cSld>
+    <p:spTree>
+      <p:nvGrpSpPr>
+        <p:cNvPr id="1" name=""/>
+        <p:cNvGrpSpPr/>
+        <p:nvPr/>
+      </p:nvGrpSpPr>
+      <p:grpSpPr>
+        <a:xfrm>
+          <a:off x="0" y="0"/>
+          <a:ext cx="0" cy="0"/>
+          <a:chOff x="0" y="0"/>
+          <a:chExt cx="0" cy="0"/>
+        </a:xfrm>
+      </p:grpSpPr>
+      <p:sp>
+        <p:nvSpPr>
+          <p:cNvPr id="2" name="Slide Image Placeholder 1"/>
+          <p:cNvSpPr>
+            <a:spLocks noGrp="1" noRot="1" noChangeAspect="1"/>
+          </p:cNvSpPr>
+          <p:nvPr>
+            <p:ph type="sldImg"/>
+          </p:nvPr>
+        </p:nvSpPr>
+        <p:spPr/>
+      </p:sp>
+      <p:sp>
+        <p:nvSpPr>
+          <p:cNvPr id="3" name="Notes Placeholder 2"/>
+          <p:cNvSpPr>
+            <a:spLocks noGrp="1"/>
+          </p:cNvSpPr>
+          <p:nvPr>
+            <p:ph type="body" idx="1"/>
+          </p:nvPr>
+        </p:nvSpPr>
+        <p:spPr/>
+        <p:txBody>
+          <a:bodyPr/>
+          <a:lstStyle/>
+          <a:p>
+            <a:r>
+              <a:rPr lang="en-US" dirty="0"/>
+              <a:t/>
+            </a:r>
+            <a:endParaRPr lang="en-US" dirty="0"/>
+          </a:p>
+        </p:txBody>
+      </p:sp>
+      <p:sp>
+        <p:nvSpPr>
+          <p:cNvPr id="4" name="Slide Number Placeholder 3"/>
+          <p:cNvSpPr>
+            <a:spLocks noGrp="1"/>
+          </p:cNvSpPr>
+          <p:nvPr>
+            <p:ph type="sldNum" sz="quarter" idx="10"/>
+          </p:nvPr>
+        </p:nvSpPr>
+        <p:spPr/>
+        <p:txBody>
+          <a:bodyPr/>
+          <a:lstStyle/>
+          <a:p>
+            <a:fld id="{F7021451-1387-4CA6-816F-3879F97B5CBC}" type="slidenum">
+              <a:rPr lang="en-US"/>
+              <a:t>12</a:t>
             </a:fld>
             <a:endParaRPr lang="en-US"/>
           </a:p>
@@ -1878,6 +2056,1076 @@
                 <a:ea typeface="Arial Black" pitchFamily="34" charset="-122"/>
                 <a:cs typeface="Arial Black" pitchFamily="34" charset="-120"/>
               </a:rPr>
+              <a:t>Tech Stack</a:t>
+            </a:r>
+            <a:endParaRPr lang="en-US" sz="3600" dirty="0"/>
+          </a:p>
+        </p:txBody>
+      </p:sp>
+      <p:sp>
+        <p:nvSpPr>
+          <p:cNvPr id="3" name="Shape 1"/>
+          <p:cNvSpPr/>
+          <p:nvPr/>
+        </p:nvSpPr>
+        <p:spPr>
+          <a:xfrm>
+            <a:off x="640080" y="1097280"/>
+            <a:ext cx="7863840" cy="594360"/>
+          </a:xfrm>
+          <a:prstGeom prst="roundRect">
+            <a:avLst>
+              <a:gd name="adj" fmla="val 12308"/>
+            </a:avLst>
+          </a:prstGeom>
+          <a:solidFill>
+            <a:srgbClr val="13131A"/>
+          </a:solidFill>
+          <a:ln/>
+        </p:spPr>
+      </p:sp>
+      <p:sp>
+        <p:nvSpPr>
+          <p:cNvPr id="4" name="Shape 2"/>
+          <p:cNvSpPr/>
+          <p:nvPr/>
+        </p:nvSpPr>
+        <p:spPr>
+          <a:xfrm>
+            <a:off x="640080" y="1097280"/>
+            <a:ext cx="54864" cy="594360"/>
+          </a:xfrm>
+          <a:prstGeom prst="rect">
+            <a:avLst/>
+          </a:prstGeom>
+          <a:solidFill>
+            <a:srgbClr val="00D4AA"/>
+          </a:solidFill>
+          <a:ln/>
+        </p:spPr>
+      </p:sp>
+      <p:sp>
+        <p:nvSpPr>
+          <p:cNvPr id="5" name="Text 3"/>
+          <p:cNvSpPr/>
+          <p:nvPr/>
+        </p:nvSpPr>
+        <p:spPr>
+          <a:xfrm>
+            <a:off x="1005840" y="1143000"/>
+            <a:ext cx="1828800" cy="274320"/>
+          </a:xfrm>
+          <a:prstGeom prst="rect">
+            <a:avLst/>
+          </a:prstGeom>
+          <a:noFill/>
+          <a:ln/>
+        </p:spPr>
+        <p:txBody>
+          <a:bodyPr wrap="square" lIns="0" tIns="0" rIns="0" bIns="0" rtlCol="0" anchor="ctr"/>
+          <a:lstStyle/>
+          <a:p>
+            <a:pPr indent="0" marL="0">
+              <a:buNone/>
+            </a:pPr>
+            <a:r>
+              <a:rPr lang="en-US" sz="1500" b="1" dirty="0">
+                <a:solidFill>
+                  <a:srgbClr val="FFFFFF"/>
+                </a:solidFill>
+                <a:latin typeface="Arial" pitchFamily="34" charset="0"/>
+                <a:ea typeface="Arial" pitchFamily="34" charset="-122"/>
+                <a:cs typeface="Arial" pitchFamily="34" charset="-120"/>
+              </a:rPr>
+              <a:t>Backend</a:t>
+            </a:r>
+            <a:endParaRPr lang="en-US" sz="1500" dirty="0"/>
+          </a:p>
+        </p:txBody>
+      </p:sp>
+      <p:sp>
+        <p:nvSpPr>
+          <p:cNvPr id="6" name="Text 4"/>
+          <p:cNvSpPr/>
+          <p:nvPr/>
+        </p:nvSpPr>
+        <p:spPr>
+          <a:xfrm>
+            <a:off x="1005840" y="1399032"/>
+            <a:ext cx="6858000" cy="228600"/>
+          </a:xfrm>
+          <a:prstGeom prst="rect">
+            <a:avLst/>
+          </a:prstGeom>
+          <a:noFill/>
+          <a:ln/>
+        </p:spPr>
+        <p:txBody>
+          <a:bodyPr wrap="square" lIns="0" tIns="0" rIns="0" bIns="0" rtlCol="0" anchor="ctr"/>
+          <a:lstStyle/>
+          <a:p>
+            <a:pPr indent="0" marL="0">
+              <a:buNone/>
+            </a:pPr>
+            <a:r>
+              <a:rPr lang="en-US" sz="1200" dirty="0">
+                <a:solidFill>
+                  <a:srgbClr val="71717A"/>
+                </a:solidFill>
+                <a:latin typeface="Arial" pitchFamily="34" charset="0"/>
+                <a:ea typeface="Arial" pitchFamily="34" charset="-122"/>
+                <a:cs typeface="Arial" pitchFamily="34" charset="-120"/>
+              </a:rPr>
+              <a:t>FastAPI + Python, scikit-learn, PyTorch</a:t>
+            </a:r>
+            <a:endParaRPr lang="en-US" sz="1200" dirty="0"/>
+          </a:p>
+        </p:txBody>
+      </p:sp>
+      <p:sp>
+        <p:nvSpPr>
+          <p:cNvPr id="7" name="Shape 5"/>
+          <p:cNvSpPr/>
+          <p:nvPr/>
+        </p:nvSpPr>
+        <p:spPr>
+          <a:xfrm>
+            <a:off x="640080" y="1828800"/>
+            <a:ext cx="7863840" cy="594360"/>
+          </a:xfrm>
+          <a:prstGeom prst="roundRect">
+            <a:avLst>
+              <a:gd name="adj" fmla="val 12308"/>
+            </a:avLst>
+          </a:prstGeom>
+          <a:solidFill>
+            <a:srgbClr val="13131A"/>
+          </a:solidFill>
+          <a:ln/>
+        </p:spPr>
+      </p:sp>
+      <p:sp>
+        <p:nvSpPr>
+          <p:cNvPr id="8" name="Shape 6"/>
+          <p:cNvSpPr/>
+          <p:nvPr/>
+        </p:nvSpPr>
+        <p:spPr>
+          <a:xfrm>
+            <a:off x="640080" y="1828800"/>
+            <a:ext cx="54864" cy="594360"/>
+          </a:xfrm>
+          <a:prstGeom prst="rect">
+            <a:avLst/>
+          </a:prstGeom>
+          <a:solidFill>
+            <a:srgbClr val="4DABF7"/>
+          </a:solidFill>
+          <a:ln/>
+        </p:spPr>
+      </p:sp>
+      <p:sp>
+        <p:nvSpPr>
+          <p:cNvPr id="9" name="Text 7"/>
+          <p:cNvSpPr/>
+          <p:nvPr/>
+        </p:nvSpPr>
+        <p:spPr>
+          <a:xfrm>
+            <a:off x="1005840" y="1874520"/>
+            <a:ext cx="1828800" cy="274320"/>
+          </a:xfrm>
+          <a:prstGeom prst="rect">
+            <a:avLst/>
+          </a:prstGeom>
+          <a:noFill/>
+          <a:ln/>
+        </p:spPr>
+        <p:txBody>
+          <a:bodyPr wrap="square" lIns="0" tIns="0" rIns="0" bIns="0" rtlCol="0" anchor="ctr"/>
+          <a:lstStyle/>
+          <a:p>
+            <a:pPr indent="0" marL="0">
+              <a:buNone/>
+            </a:pPr>
+            <a:r>
+              <a:rPr lang="en-US" sz="1500" b="1" dirty="0">
+                <a:solidFill>
+                  <a:srgbClr val="FFFFFF"/>
+                </a:solidFill>
+                <a:latin typeface="Arial" pitchFamily="34" charset="0"/>
+                <a:ea typeface="Arial" pitchFamily="34" charset="-122"/>
+                <a:cs typeface="Arial" pitchFamily="34" charset="-120"/>
+              </a:rPr>
+              <a:t>Frontend</a:t>
+            </a:r>
+            <a:endParaRPr lang="en-US" sz="1500" dirty="0"/>
+          </a:p>
+        </p:txBody>
+      </p:sp>
+      <p:sp>
+        <p:nvSpPr>
+          <p:cNvPr id="10" name="Text 8"/>
+          <p:cNvSpPr/>
+          <p:nvPr/>
+        </p:nvSpPr>
+        <p:spPr>
+          <a:xfrm>
+            <a:off x="1005840" y="2130552"/>
+            <a:ext cx="6858000" cy="228600"/>
+          </a:xfrm>
+          <a:prstGeom prst="rect">
+            <a:avLst/>
+          </a:prstGeom>
+          <a:noFill/>
+          <a:ln/>
+        </p:spPr>
+        <p:txBody>
+          <a:bodyPr wrap="square" lIns="0" tIns="0" rIns="0" bIns="0" rtlCol="0" anchor="ctr"/>
+          <a:lstStyle/>
+          <a:p>
+            <a:pPr indent="0" marL="0">
+              <a:buNone/>
+            </a:pPr>
+            <a:r>
+              <a:rPr lang="en-US" sz="1200" dirty="0">
+                <a:solidFill>
+                  <a:srgbClr val="71717A"/>
+                </a:solidFill>
+                <a:latin typeface="Arial" pitchFamily="34" charset="0"/>
+                <a:ea typeface="Arial" pitchFamily="34" charset="-122"/>
+                <a:cs typeface="Arial" pitchFamily="34" charset="-120"/>
+              </a:rPr>
+              <a:t>Next.js 14, React 18, TailwindCSS</a:t>
+            </a:r>
+            <a:endParaRPr lang="en-US" sz="1200" dirty="0"/>
+          </a:p>
+        </p:txBody>
+      </p:sp>
+      <p:sp>
+        <p:nvSpPr>
+          <p:cNvPr id="11" name="Shape 9"/>
+          <p:cNvSpPr/>
+          <p:nvPr/>
+        </p:nvSpPr>
+        <p:spPr>
+          <a:xfrm>
+            <a:off x="640080" y="2560320"/>
+            <a:ext cx="7863840" cy="594360"/>
+          </a:xfrm>
+          <a:prstGeom prst="roundRect">
+            <a:avLst>
+              <a:gd name="adj" fmla="val 12308"/>
+            </a:avLst>
+          </a:prstGeom>
+          <a:solidFill>
+            <a:srgbClr val="13131A"/>
+          </a:solidFill>
+          <a:ln/>
+        </p:spPr>
+      </p:sp>
+      <p:sp>
+        <p:nvSpPr>
+          <p:cNvPr id="12" name="Shape 10"/>
+          <p:cNvSpPr/>
+          <p:nvPr/>
+        </p:nvSpPr>
+        <p:spPr>
+          <a:xfrm>
+            <a:off x="640080" y="2560320"/>
+            <a:ext cx="54864" cy="594360"/>
+          </a:xfrm>
+          <a:prstGeom prst="rect">
+            <a:avLst/>
+          </a:prstGeom>
+          <a:solidFill>
+            <a:srgbClr val="6C5CE7"/>
+          </a:solidFill>
+          <a:ln/>
+        </p:spPr>
+      </p:sp>
+      <p:sp>
+        <p:nvSpPr>
+          <p:cNvPr id="13" name="Text 11"/>
+          <p:cNvSpPr/>
+          <p:nvPr/>
+        </p:nvSpPr>
+        <p:spPr>
+          <a:xfrm>
+            <a:off x="1005840" y="2606040"/>
+            <a:ext cx="1828800" cy="274320"/>
+          </a:xfrm>
+          <a:prstGeom prst="rect">
+            <a:avLst/>
+          </a:prstGeom>
+          <a:noFill/>
+          <a:ln/>
+        </p:spPr>
+        <p:txBody>
+          <a:bodyPr wrap="square" lIns="0" tIns="0" rIns="0" bIns="0" rtlCol="0" anchor="ctr"/>
+          <a:lstStyle/>
+          <a:p>
+            <a:pPr indent="0" marL="0">
+              <a:buNone/>
+            </a:pPr>
+            <a:r>
+              <a:rPr lang="en-US" sz="1500" b="1" dirty="0">
+                <a:solidFill>
+                  <a:srgbClr val="FFFFFF"/>
+                </a:solidFill>
+                <a:latin typeface="Arial" pitchFamily="34" charset="0"/>
+                <a:ea typeface="Arial" pitchFamily="34" charset="-122"/>
+                <a:cs typeface="Arial" pitchFamily="34" charset="-120"/>
+              </a:rPr>
+              <a:t>Data</a:t>
+            </a:r>
+            <a:endParaRPr lang="en-US" sz="1500" dirty="0"/>
+          </a:p>
+        </p:txBody>
+      </p:sp>
+      <p:sp>
+        <p:nvSpPr>
+          <p:cNvPr id="14" name="Text 12"/>
+          <p:cNvSpPr/>
+          <p:nvPr/>
+        </p:nvSpPr>
+        <p:spPr>
+          <a:xfrm>
+            <a:off x="1005840" y="2862072"/>
+            <a:ext cx="6858000" cy="228600"/>
+          </a:xfrm>
+          <a:prstGeom prst="rect">
+            <a:avLst/>
+          </a:prstGeom>
+          <a:noFill/>
+          <a:ln/>
+        </p:spPr>
+        <p:txBody>
+          <a:bodyPr wrap="square" lIns="0" tIns="0" rIns="0" bIns="0" rtlCol="0" anchor="ctr"/>
+          <a:lstStyle/>
+          <a:p>
+            <a:pPr indent="0" marL="0">
+              <a:buNone/>
+            </a:pPr>
+            <a:r>
+              <a:rPr lang="en-US" sz="1200" dirty="0">
+                <a:solidFill>
+                  <a:srgbClr val="71717A"/>
+                </a:solidFill>
+                <a:latin typeface="Arial" pitchFamily="34" charset="0"/>
+                <a:ea typeface="Arial" pitchFamily="34" charset="-122"/>
+                <a:cs typeface="Arial" pitchFamily="34" charset="-120"/>
+              </a:rPr>
+              <a:t>BGeometrics Premium, Binance.US, Coinbase, Polymarket</a:t>
+            </a:r>
+            <a:endParaRPr lang="en-US" sz="1200" dirty="0"/>
+          </a:p>
+        </p:txBody>
+      </p:sp>
+      <p:sp>
+        <p:nvSpPr>
+          <p:cNvPr id="15" name="Shape 13"/>
+          <p:cNvSpPr/>
+          <p:nvPr/>
+        </p:nvSpPr>
+        <p:spPr>
+          <a:xfrm>
+            <a:off x="640080" y="3291840"/>
+            <a:ext cx="7863840" cy="594360"/>
+          </a:xfrm>
+          <a:prstGeom prst="roundRect">
+            <a:avLst>
+              <a:gd name="adj" fmla="val 12308"/>
+            </a:avLst>
+          </a:prstGeom>
+          <a:solidFill>
+            <a:srgbClr val="13131A"/>
+          </a:solidFill>
+          <a:ln/>
+        </p:spPr>
+      </p:sp>
+      <p:sp>
+        <p:nvSpPr>
+          <p:cNvPr id="16" name="Shape 14"/>
+          <p:cNvSpPr/>
+          <p:nvPr/>
+        </p:nvSpPr>
+        <p:spPr>
+          <a:xfrm>
+            <a:off x="640080" y="3291840"/>
+            <a:ext cx="54864" cy="594360"/>
+          </a:xfrm>
+          <a:prstGeom prst="rect">
+            <a:avLst/>
+          </a:prstGeom>
+          <a:solidFill>
+            <a:srgbClr val="FFD93D"/>
+          </a:solidFill>
+          <a:ln/>
+        </p:spPr>
+      </p:sp>
+      <p:sp>
+        <p:nvSpPr>
+          <p:cNvPr id="17" name="Text 15"/>
+          <p:cNvSpPr/>
+          <p:nvPr/>
+        </p:nvSpPr>
+        <p:spPr>
+          <a:xfrm>
+            <a:off x="1005840" y="3337560"/>
+            <a:ext cx="1828800" cy="274320"/>
+          </a:xfrm>
+          <a:prstGeom prst="rect">
+            <a:avLst/>
+          </a:prstGeom>
+          <a:noFill/>
+          <a:ln/>
+        </p:spPr>
+        <p:txBody>
+          <a:bodyPr wrap="square" lIns="0" tIns="0" rIns="0" bIns="0" rtlCol="0" anchor="ctr"/>
+          <a:lstStyle/>
+          <a:p>
+            <a:pPr indent="0" marL="0">
+              <a:buNone/>
+            </a:pPr>
+            <a:r>
+              <a:rPr lang="en-US" sz="1500" b="1" dirty="0">
+                <a:solidFill>
+                  <a:srgbClr val="FFFFFF"/>
+                </a:solidFill>
+                <a:latin typeface="Arial" pitchFamily="34" charset="0"/>
+                <a:ea typeface="Arial" pitchFamily="34" charset="-122"/>
+                <a:cs typeface="Arial" pitchFamily="34" charset="-120"/>
+              </a:rPr>
+              <a:t>Price</a:t>
+            </a:r>
+            <a:endParaRPr lang="en-US" sz="1500" dirty="0"/>
+          </a:p>
+        </p:txBody>
+      </p:sp>
+      <p:sp>
+        <p:nvSpPr>
+          <p:cNvPr id="18" name="Text 16"/>
+          <p:cNvSpPr/>
+          <p:nvPr/>
+        </p:nvSpPr>
+        <p:spPr>
+          <a:xfrm>
+            <a:off x="1005840" y="3593592"/>
+            <a:ext cx="6858000" cy="228600"/>
+          </a:xfrm>
+          <a:prstGeom prst="rect">
+            <a:avLst/>
+          </a:prstGeom>
+          <a:noFill/>
+          <a:ln/>
+        </p:spPr>
+        <p:txBody>
+          <a:bodyPr wrap="square" lIns="0" tIns="0" rIns="0" bIns="0" rtlCol="0" anchor="ctr"/>
+          <a:lstStyle/>
+          <a:p>
+            <a:pPr indent="0" marL="0">
+              <a:buNone/>
+            </a:pPr>
+            <a:r>
+              <a:rPr lang="en-US" sz="1200" dirty="0">
+                <a:solidFill>
+                  <a:srgbClr val="71717A"/>
+                </a:solidFill>
+                <a:latin typeface="Arial" pitchFamily="34" charset="0"/>
+                <a:ea typeface="Arial" pitchFamily="34" charset="-122"/>
+                <a:cs typeface="Arial" pitchFamily="34" charset="-120"/>
+              </a:rPr>
+              <a:t>TrueMarkets MCP (same source everywhere)</a:t>
+            </a:r>
+            <a:endParaRPr lang="en-US" sz="1200" dirty="0"/>
+          </a:p>
+        </p:txBody>
+      </p:sp>
+      <p:sp>
+        <p:nvSpPr>
+          <p:cNvPr id="19" name="Shape 17"/>
+          <p:cNvSpPr/>
+          <p:nvPr/>
+        </p:nvSpPr>
+        <p:spPr>
+          <a:xfrm>
+            <a:off x="640080" y="4023360"/>
+            <a:ext cx="7863840" cy="594360"/>
+          </a:xfrm>
+          <a:prstGeom prst="roundRect">
+            <a:avLst>
+              <a:gd name="adj" fmla="val 12308"/>
+            </a:avLst>
+          </a:prstGeom>
+          <a:solidFill>
+            <a:srgbClr val="13131A"/>
+          </a:solidFill>
+          <a:ln/>
+        </p:spPr>
+      </p:sp>
+      <p:sp>
+        <p:nvSpPr>
+          <p:cNvPr id="20" name="Shape 18"/>
+          <p:cNvSpPr/>
+          <p:nvPr/>
+        </p:nvSpPr>
+        <p:spPr>
+          <a:xfrm>
+            <a:off x="640080" y="4023360"/>
+            <a:ext cx="54864" cy="594360"/>
+          </a:xfrm>
+          <a:prstGeom prst="rect">
+            <a:avLst/>
+          </a:prstGeom>
+          <a:solidFill>
+            <a:srgbClr val="FF6B6B"/>
+          </a:solidFill>
+          <a:ln/>
+        </p:spPr>
+      </p:sp>
+      <p:sp>
+        <p:nvSpPr>
+          <p:cNvPr id="21" name="Text 19"/>
+          <p:cNvSpPr/>
+          <p:nvPr/>
+        </p:nvSpPr>
+        <p:spPr>
+          <a:xfrm>
+            <a:off x="1005840" y="4069080"/>
+            <a:ext cx="1828800" cy="274320"/>
+          </a:xfrm>
+          <a:prstGeom prst="rect">
+            <a:avLst/>
+          </a:prstGeom>
+          <a:noFill/>
+          <a:ln/>
+        </p:spPr>
+        <p:txBody>
+          <a:bodyPr wrap="square" lIns="0" tIns="0" rIns="0" bIns="0" rtlCol="0" anchor="ctr"/>
+          <a:lstStyle/>
+          <a:p>
+            <a:pPr indent="0" marL="0">
+              <a:buNone/>
+            </a:pPr>
+            <a:r>
+              <a:rPr lang="en-US" sz="1500" b="1" dirty="0">
+                <a:solidFill>
+                  <a:srgbClr val="FFFFFF"/>
+                </a:solidFill>
+                <a:latin typeface="Arial" pitchFamily="34" charset="0"/>
+                <a:ea typeface="Arial" pitchFamily="34" charset="-122"/>
+                <a:cs typeface="Arial" pitchFamily="34" charset="-120"/>
+              </a:rPr>
+              <a:t>Refresh</a:t>
+            </a:r>
+            <a:endParaRPr lang="en-US" sz="1500" dirty="0"/>
+          </a:p>
+        </p:txBody>
+      </p:sp>
+      <p:sp>
+        <p:nvSpPr>
+          <p:cNvPr id="22" name="Text 20"/>
+          <p:cNvSpPr/>
+          <p:nvPr/>
+        </p:nvSpPr>
+        <p:spPr>
+          <a:xfrm>
+            <a:off x="1005840" y="4325112"/>
+            <a:ext cx="6858000" cy="228600"/>
+          </a:xfrm>
+          <a:prstGeom prst="rect">
+            <a:avLst/>
+          </a:prstGeom>
+          <a:noFill/>
+          <a:ln/>
+        </p:spPr>
+        <p:txBody>
+          <a:bodyPr wrap="square" lIns="0" tIns="0" rIns="0" bIns="0" rtlCol="0" anchor="ctr"/>
+          <a:lstStyle/>
+          <a:p>
+            <a:pPr indent="0" marL="0">
+              <a:buNone/>
+            </a:pPr>
+            <a:r>
+              <a:rPr lang="en-US" sz="1200" dirty="0">
+                <a:solidFill>
+                  <a:srgbClr val="71717A"/>
+                </a:solidFill>
+                <a:latin typeface="Arial" pitchFamily="34" charset="0"/>
+                <a:ea typeface="Arial" pitchFamily="34" charset="-122"/>
+                <a:cs typeface="Arial" pitchFamily="34" charset="-120"/>
+              </a:rPr>
+              <a:t>30 seconds, all 6 signals</a:t>
+            </a:r>
+            <a:endParaRPr lang="en-US" sz="1200" dirty="0"/>
+          </a:p>
+        </p:txBody>
+      </p:sp>
+    </p:spTree>
+  </p:cSld>
+  <p:clrMapOvr>
+    <a:masterClrMapping/>
+  </p:clrMapOvr>
+</p:sld>
+</file>
+
+<file path=ppt/slides/slide11.xml><?xml version="1.0" encoding="utf-8"?>
+<p:sld xmlns:a="http://schemas.openxmlformats.org/drawingml/2006/main" xmlns:r="http://schemas.openxmlformats.org/officeDocument/2006/relationships" xmlns:p="http://schemas.openxmlformats.org/presentationml/2006/main">
+  <p:cSld name="Slide 11">
+    <p:bg>
+      <p:bgPr>
+        <a:solidFill>
+          <a:srgbClr val="0A0A0F"/>
+        </a:solidFill>
+      </p:bgPr>
+    </p:bg>
+    <p:spTree>
+      <p:nvGrpSpPr>
+        <p:cNvPr id="1" name=""/>
+        <p:cNvGrpSpPr/>
+        <p:nvPr/>
+      </p:nvGrpSpPr>
+      <p:grpSpPr>
+        <a:xfrm>
+          <a:off x="0" y="0"/>
+          <a:ext cx="0" cy="0"/>
+          <a:chOff x="0" y="0"/>
+          <a:chExt cx="0" cy="0"/>
+        </a:xfrm>
+      </p:grpSpPr>
+      <p:sp>
+        <p:nvSpPr>
+          <p:cNvPr id="2" name="Text 0"/>
+          <p:cNvSpPr/>
+          <p:nvPr/>
+        </p:nvSpPr>
+        <p:spPr>
+          <a:xfrm>
+            <a:off x="640080" y="365760"/>
+            <a:ext cx="7315200" cy="548640"/>
+          </a:xfrm>
+          <a:prstGeom prst="rect">
+            <a:avLst/>
+          </a:prstGeom>
+          <a:noFill/>
+          <a:ln/>
+        </p:spPr>
+        <p:txBody>
+          <a:bodyPr wrap="square" lIns="0" tIns="0" rIns="0" bIns="0" rtlCol="0" anchor="ctr"/>
+          <a:lstStyle/>
+          <a:p>
+            <a:pPr indent="0" marL="0">
+              <a:buNone/>
+            </a:pPr>
+            <a:r>
+              <a:rPr lang="en-US" sz="3600" b="1" dirty="0">
+                <a:solidFill>
+                  <a:srgbClr val="FFFFFF"/>
+                </a:solidFill>
+                <a:latin typeface="Arial Black" pitchFamily="34" charset="0"/>
+                <a:ea typeface="Arial Black" pitchFamily="34" charset="-122"/>
+                <a:cs typeface="Arial Black" pitchFamily="34" charset="-120"/>
+              </a:rPr>
+              <a:t>The Product</a:t>
+            </a:r>
+            <a:endParaRPr lang="en-US" sz="3600" dirty="0"/>
+          </a:p>
+        </p:txBody>
+      </p:sp>
+      <p:sp>
+        <p:nvSpPr>
+          <p:cNvPr id="3" name="Shape 1"/>
+          <p:cNvSpPr/>
+          <p:nvPr/>
+        </p:nvSpPr>
+        <p:spPr>
+          <a:xfrm>
+            <a:off x="640080" y="1097280"/>
+            <a:ext cx="3749040" cy="3474720"/>
+          </a:xfrm>
+          <a:prstGeom prst="roundRect">
+            <a:avLst>
+              <a:gd name="adj" fmla="val 2632"/>
+            </a:avLst>
+          </a:prstGeom>
+          <a:solidFill>
+            <a:srgbClr val="13131A"/>
+          </a:solidFill>
+          <a:ln/>
+        </p:spPr>
+      </p:sp>
+      <p:sp>
+        <p:nvSpPr>
+          <p:cNvPr id="4" name="Text 2"/>
+          <p:cNvSpPr/>
+          <p:nvPr/>
+        </p:nvSpPr>
+        <p:spPr>
+          <a:xfrm>
+            <a:off x="822960" y="1188720"/>
+            <a:ext cx="3200400" cy="365760"/>
+          </a:xfrm>
+          <a:prstGeom prst="rect">
+            <a:avLst/>
+          </a:prstGeom>
+          <a:noFill/>
+          <a:ln/>
+        </p:spPr>
+        <p:txBody>
+          <a:bodyPr wrap="square" lIns="0" tIns="0" rIns="0" bIns="0" rtlCol="0" anchor="ctr"/>
+          <a:lstStyle/>
+          <a:p>
+            <a:pPr indent="0" marL="0">
+              <a:buNone/>
+            </a:pPr>
+            <a:r>
+              <a:rPr lang="en-US" sz="1800" b="1" dirty="0">
+                <a:solidFill>
+                  <a:srgbClr val="00D4AA"/>
+                </a:solidFill>
+                <a:latin typeface="Arial" pitchFamily="34" charset="0"/>
+                <a:ea typeface="Arial" pitchFamily="34" charset="-122"/>
+                <a:cs typeface="Arial" pitchFamily="34" charset="-120"/>
+              </a:rPr>
+              <a:t>Market Page</a:t>
+            </a:r>
+            <a:endParaRPr lang="en-US" sz="1800" dirty="0"/>
+          </a:p>
+        </p:txBody>
+      </p:sp>
+      <p:sp>
+        <p:nvSpPr>
+          <p:cNvPr id="5" name="Text 3"/>
+          <p:cNvSpPr/>
+          <p:nvPr/>
+        </p:nvSpPr>
+        <p:spPr>
+          <a:xfrm>
+            <a:off x="822960" y="1645920"/>
+            <a:ext cx="3383280" cy="2286000"/>
+          </a:xfrm>
+          <a:prstGeom prst="rect">
+            <a:avLst/>
+          </a:prstGeom>
+          <a:noFill/>
+          <a:ln/>
+        </p:spPr>
+        <p:txBody>
+          <a:bodyPr wrap="square" rtlCol="0" anchor="ctr"/>
+          <a:lstStyle/>
+          <a:p>
+            <a:pPr marL="342900" indent="-342900">
+              <a:buSzPct val="100000"/>
+              <a:buChar char="•"/>
+            </a:pPr>
+            <a:r>
+              <a:rPr lang="en-US" sz="1200" dirty="0">
+                <a:solidFill>
+                  <a:srgbClr val="E4E4E7"/>
+                </a:solidFill>
+                <a:latin typeface="Arial" pitchFamily="34" charset="0"/>
+                <a:ea typeface="Arial" pitchFamily="34" charset="-122"/>
+                <a:cs typeface="Arial" pitchFamily="34" charset="-120"/>
+              </a:rPr>
+              <a:t>Live BTC price + chart</a:t>
+            </a:r>
+            <a:endParaRPr lang="en-US" sz="1200" dirty="0"/>
+          </a:p>
+          <a:p>
+            <a:pPr marL="342900" indent="-342900">
+              <a:buSzPct val="100000"/>
+              <a:buChar char="•"/>
+            </a:pPr>
+            <a:r>
+              <a:rPr lang="en-US" sz="1200" dirty="0">
+                <a:solidFill>
+                  <a:srgbClr val="E4E4E7"/>
+                </a:solidFill>
+                <a:latin typeface="Arial" pitchFamily="34" charset="0"/>
+                <a:ea typeface="Arial" pitchFamily="34" charset="-122"/>
+                <a:cs typeface="Arial" pitchFamily="34" charset="-120"/>
+              </a:rPr>
+              <a:t>Market cap, volume, highs/lows</a:t>
+            </a:r>
+            <a:endParaRPr lang="en-US" sz="1200" dirty="0"/>
+          </a:p>
+          <a:p>
+            <a:pPr marL="342900" indent="-342900">
+              <a:buSzPct val="100000"/>
+              <a:buChar char="•"/>
+            </a:pPr>
+            <a:r>
+              <a:rPr lang="en-US" sz="1200" dirty="0">
+                <a:solidFill>
+                  <a:srgbClr val="E4E4E7"/>
+                </a:solidFill>
+                <a:latin typeface="Arial" pitchFamily="34" charset="0"/>
+                <a:ea typeface="Arial" pitchFamily="34" charset="-122"/>
+                <a:cs typeface="Arial" pitchFamily="34" charset="-120"/>
+              </a:rPr>
+              <a:t>Fear &amp; Greed Index</a:t>
+            </a:r>
+            <a:endParaRPr lang="en-US" sz="1200" dirty="0"/>
+          </a:p>
+          <a:p>
+            <a:pPr marL="342900" indent="-342900">
+              <a:buSzPct val="100000"/>
+              <a:buChar char="•"/>
+            </a:pPr>
+            <a:r>
+              <a:rPr lang="en-US" sz="1200" dirty="0">
+                <a:solidFill>
+                  <a:srgbClr val="E4E4E7"/>
+                </a:solidFill>
+                <a:latin typeface="Arial" pitchFamily="34" charset="0"/>
+                <a:ea typeface="Arial" pitchFamily="34" charset="-122"/>
+                <a:cs typeface="Arial" pitchFamily="34" charset="-120"/>
+              </a:rPr>
+              <a:t>TM Sentiment (30+ sources)</a:t>
+            </a:r>
+            <a:endParaRPr lang="en-US" sz="1200" dirty="0"/>
+          </a:p>
+        </p:txBody>
+      </p:sp>
+      <p:sp>
+        <p:nvSpPr>
+          <p:cNvPr id="6" name="Shape 4"/>
+          <p:cNvSpPr/>
+          <p:nvPr/>
+        </p:nvSpPr>
+        <p:spPr>
+          <a:xfrm>
+            <a:off x="4754880" y="1097280"/>
+            <a:ext cx="3931920" cy="3474720"/>
+          </a:xfrm>
+          <a:prstGeom prst="roundRect">
+            <a:avLst>
+              <a:gd name="adj" fmla="val 2632"/>
+            </a:avLst>
+          </a:prstGeom>
+          <a:solidFill>
+            <a:srgbClr val="13131A"/>
+          </a:solidFill>
+          <a:ln/>
+        </p:spPr>
+      </p:sp>
+      <p:sp>
+        <p:nvSpPr>
+          <p:cNvPr id="7" name="Text 5"/>
+          <p:cNvSpPr/>
+          <p:nvPr/>
+        </p:nvSpPr>
+        <p:spPr>
+          <a:xfrm>
+            <a:off x="4937760" y="1188720"/>
+            <a:ext cx="3200400" cy="365760"/>
+          </a:xfrm>
+          <a:prstGeom prst="rect">
+            <a:avLst/>
+          </a:prstGeom>
+          <a:noFill/>
+          <a:ln/>
+        </p:spPr>
+        <p:txBody>
+          <a:bodyPr wrap="square" lIns="0" tIns="0" rIns="0" bIns="0" rtlCol="0" anchor="ctr"/>
+          <a:lstStyle/>
+          <a:p>
+            <a:pPr indent="0" marL="0">
+              <a:buNone/>
+            </a:pPr>
+            <a:r>
+              <a:rPr lang="en-US" sz="1800" b="1" dirty="0">
+                <a:solidFill>
+                  <a:srgbClr val="6C5CE7"/>
+                </a:solidFill>
+                <a:latin typeface="Arial" pitchFamily="34" charset="0"/>
+                <a:ea typeface="Arial" pitchFamily="34" charset="-122"/>
+                <a:cs typeface="Arial" pitchFamily="34" charset="-120"/>
+              </a:rPr>
+              <a:t>Prediction Page</a:t>
+            </a:r>
+            <a:endParaRPr lang="en-US" sz="1800" dirty="0"/>
+          </a:p>
+        </p:txBody>
+      </p:sp>
+      <p:sp>
+        <p:nvSpPr>
+          <p:cNvPr id="8" name="Text 6"/>
+          <p:cNvSpPr/>
+          <p:nvPr/>
+        </p:nvSpPr>
+        <p:spPr>
+          <a:xfrm>
+            <a:off x="4937760" y="1645920"/>
+            <a:ext cx="3566160" cy="2286000"/>
+          </a:xfrm>
+          <a:prstGeom prst="rect">
+            <a:avLst/>
+          </a:prstGeom>
+          <a:noFill/>
+          <a:ln/>
+        </p:spPr>
+        <p:txBody>
+          <a:bodyPr wrap="square" rtlCol="0" anchor="ctr"/>
+          <a:lstStyle/>
+          <a:p>
+            <a:pPr marL="342900" indent="-342900">
+              <a:buSzPct val="100000"/>
+              <a:buChar char="•"/>
+            </a:pPr>
+            <a:r>
+              <a:rPr lang="en-US" sz="1200" dirty="0">
+                <a:solidFill>
+                  <a:srgbClr val="E4E4E7"/>
+                </a:solidFill>
+                <a:latin typeface="Arial" pitchFamily="34" charset="0"/>
+                <a:ea typeface="Arial" pitchFamily="34" charset="-122"/>
+                <a:cs typeface="Arial" pitchFamily="34" charset="-120"/>
+              </a:rPr>
+              <a:t>BUY / SELL with 6-signal reasoning</a:t>
+            </a:r>
+            <a:endParaRPr lang="en-US" sz="1200" dirty="0"/>
+          </a:p>
+          <a:p>
+            <a:pPr marL="342900" indent="-342900">
+              <a:buSzPct val="100000"/>
+              <a:buChar char="•"/>
+            </a:pPr>
+            <a:r>
+              <a:rPr lang="en-US" sz="1200" dirty="0">
+                <a:solidFill>
+                  <a:srgbClr val="E4E4E7"/>
+                </a:solidFill>
+                <a:latin typeface="Arial" pitchFamily="34" charset="0"/>
+                <a:ea typeface="Arial" pitchFamily="34" charset="-122"/>
+                <a:cs typeface="Arial" pitchFamily="34" charset="-120"/>
+              </a:rPr>
+              <a:t>Polymarket table (18 thresholds)</a:t>
+            </a:r>
+            <a:endParaRPr lang="en-US" sz="1200" dirty="0"/>
+          </a:p>
+          <a:p>
+            <a:pPr marL="342900" indent="-342900">
+              <a:buSzPct val="100000"/>
+              <a:buChar char="•"/>
+            </a:pPr>
+            <a:r>
+              <a:rPr lang="en-US" sz="1200" dirty="0">
+                <a:solidFill>
+                  <a:srgbClr val="E4E4E7"/>
+                </a:solidFill>
+                <a:latin typeface="Arial" pitchFamily="34" charset="0"/>
+                <a:ea typeface="Arial" pitchFamily="34" charset="-122"/>
+                <a:cs typeface="Arial" pitchFamily="34" charset="-120"/>
+              </a:rPr>
+              <a:t>Binance order flow visualization</a:t>
+            </a:r>
+            <a:endParaRPr lang="en-US" sz="1200" dirty="0"/>
+          </a:p>
+          <a:p>
+            <a:pPr marL="342900" indent="-342900">
+              <a:buSzPct val="100000"/>
+              <a:buChar char="•"/>
+            </a:pPr>
+            <a:r>
+              <a:rPr lang="en-US" sz="1200" dirty="0">
+                <a:solidFill>
+                  <a:srgbClr val="E4E4E7"/>
+                </a:solidFill>
+                <a:latin typeface="Arial" pitchFamily="34" charset="0"/>
+                <a:ea typeface="Arial" pitchFamily="34" charset="-122"/>
+                <a:cs typeface="Arial" pitchFamily="34" charset="-120"/>
+              </a:rPr>
+              <a:t>RSI, MACD, Bollinger live</a:t>
+            </a:r>
+            <a:endParaRPr lang="en-US" sz="1200" dirty="0"/>
+          </a:p>
+          <a:p>
+            <a:pPr marL="342900" indent="-342900">
+              <a:buSzPct val="100000"/>
+              <a:buChar char="•"/>
+            </a:pPr>
+            <a:r>
+              <a:rPr lang="en-US" sz="1200" dirty="0">
+                <a:solidFill>
+                  <a:srgbClr val="E4E4E7"/>
+                </a:solidFill>
+                <a:latin typeface="Arial" pitchFamily="34" charset="0"/>
+                <a:ea typeface="Arial" pitchFamily="34" charset="-122"/>
+                <a:cs typeface="Arial" pitchFamily="34" charset="-120"/>
+              </a:rPr>
+              <a:t>Portfolio + order management</a:t>
+            </a:r>
+            <a:endParaRPr lang="en-US" sz="1200" dirty="0"/>
+          </a:p>
+        </p:txBody>
+      </p:sp>
+    </p:spTree>
+  </p:cSld>
+  <p:clrMapOvr>
+    <a:masterClrMapping/>
+  </p:clrMapOvr>
+</p:sld>
+</file>
+
+<file path=ppt/slides/slide12.xml><?xml version="1.0" encoding="utf-8"?>
+<p:sld xmlns:a="http://schemas.openxmlformats.org/drawingml/2006/main" xmlns:r="http://schemas.openxmlformats.org/officeDocument/2006/relationships" xmlns:p="http://schemas.openxmlformats.org/presentationml/2006/main">
+  <p:cSld name="Slide 12">
+    <p:bg>
+      <p:bgPr>
+        <a:solidFill>
+          <a:srgbClr val="0A0A0F"/>
+        </a:solidFill>
+      </p:bgPr>
+    </p:bg>
+    <p:spTree>
+      <p:nvGrpSpPr>
+        <p:cNvPr id="1" name=""/>
+        <p:cNvGrpSpPr/>
+        <p:nvPr/>
+      </p:nvGrpSpPr>
+      <p:grpSpPr>
+        <a:xfrm>
+          <a:off x="0" y="0"/>
+          <a:ext cx="0" cy="0"/>
+          <a:chOff x="0" y="0"/>
+          <a:chExt cx="0" cy="0"/>
+        </a:xfrm>
+      </p:grpSpPr>
+      <p:sp>
+        <p:nvSpPr>
+          <p:cNvPr id="2" name="Text 0"/>
+          <p:cNvSpPr/>
+          <p:nvPr/>
+        </p:nvSpPr>
+        <p:spPr>
+          <a:xfrm>
+            <a:off x="640080" y="365760"/>
+            <a:ext cx="7315200" cy="548640"/>
+          </a:xfrm>
+          <a:prstGeom prst="rect">
+            <a:avLst/>
+          </a:prstGeom>
+          <a:noFill/>
+          <a:ln/>
+        </p:spPr>
+        <p:txBody>
+          <a:bodyPr wrap="square" lIns="0" tIns="0" rIns="0" bIns="0" rtlCol="0" anchor="ctr"/>
+          <a:lstStyle/>
+          <a:p>
+            <a:pPr indent="0" marL="0">
+              <a:buNone/>
+            </a:pPr>
+            <a:r>
+              <a:rPr lang="en-US" sz="3600" b="1" dirty="0">
+                <a:solidFill>
+                  <a:srgbClr val="FFFFFF"/>
+                </a:solidFill>
+                <a:latin typeface="Arial Black" pitchFamily="34" charset="0"/>
+                <a:ea typeface="Arial Black" pitchFamily="34" charset="-122"/>
+                <a:cs typeface="Arial Black" pitchFamily="34" charset="-120"/>
+              </a:rPr>
               <a:t>The Ask</a:t>
             </a:r>
             <a:endParaRPr lang="en-US" sz="3600" dirty="0"/>
@@ -5557,24 +6805,24 @@
         </p:nvSpPr>
         <p:spPr>
           <a:xfrm>
-            <a:off x="640080" y="365760"/>
-            <a:ext cx="7315200" cy="548640"/>
-          </a:xfrm>
-          <a:prstGeom prst="rect">
-            <a:avLst/>
-          </a:prstGeom>
-          <a:noFill/>
-          <a:ln/>
-        </p:spPr>
-        <p:txBody>
-          <a:bodyPr wrap="square" lIns="0" tIns="0" rIns="0" bIns="0" rtlCol="0" anchor="ctr"/>
-          <a:lstStyle/>
-          <a:p>
-            <a:pPr indent="0" marL="0">
-              <a:buNone/>
-            </a:pPr>
-            <a:r>
-              <a:rPr lang="en-US" sz="3600" b="1" dirty="0">
+            <a:off x="640080" y="274320"/>
+            <a:ext cx="5486400" cy="457200"/>
+          </a:xfrm>
+          <a:prstGeom prst="rect">
+            <a:avLst/>
+          </a:prstGeom>
+          <a:noFill/>
+          <a:ln/>
+        </p:spPr>
+        <p:txBody>
+          <a:bodyPr wrap="square" lIns="0" tIns="0" rIns="0" bIns="0" rtlCol="0" anchor="ctr"/>
+          <a:lstStyle/>
+          <a:p>
+            <a:pPr indent="0" marL="0">
+              <a:buNone/>
+            </a:pPr>
+            <a:r>
+              <a:rPr lang="en-US" sz="3000" b="1" dirty="0">
                 <a:solidFill>
                   <a:srgbClr val="FFFFFF"/>
                 </a:solidFill>
@@ -5582,119 +6830,38 @@
                 <a:ea typeface="Arial Black" pitchFamily="34" charset="-122"/>
                 <a:cs typeface="Arial Black" pitchFamily="34" charset="-120"/>
               </a:rPr>
-              <a:t>Tech Stack</a:t>
-            </a:r>
-            <a:endParaRPr lang="en-US" sz="3600" dirty="0"/>
-          </a:p>
-        </p:txBody>
-      </p:sp>
-      <p:sp>
-        <p:nvSpPr>
-          <p:cNvPr id="3" name="Shape 1"/>
-          <p:cNvSpPr/>
-          <p:nvPr/>
-        </p:nvSpPr>
-        <p:spPr>
-          <a:xfrm>
-            <a:off x="640080" y="1097280"/>
-            <a:ext cx="7863840" cy="594360"/>
-          </a:xfrm>
-          <a:prstGeom prst="roundRect">
-            <a:avLst>
-              <a:gd name="adj" fmla="val 12308"/>
-            </a:avLst>
-          </a:prstGeom>
-          <a:solidFill>
-            <a:srgbClr val="13131A"/>
-          </a:solidFill>
-          <a:ln/>
-        </p:spPr>
-      </p:sp>
-      <p:sp>
-        <p:nvSpPr>
-          <p:cNvPr id="4" name="Shape 2"/>
-          <p:cNvSpPr/>
-          <p:nvPr/>
-        </p:nvSpPr>
-        <p:spPr>
-          <a:xfrm>
-            <a:off x="640080" y="1097280"/>
-            <a:ext cx="54864" cy="594360"/>
-          </a:xfrm>
-          <a:prstGeom prst="rect">
-            <a:avLst/>
-          </a:prstGeom>
-          <a:solidFill>
-            <a:srgbClr val="00D4AA"/>
-          </a:solidFill>
-          <a:ln/>
-        </p:spPr>
-      </p:sp>
-      <p:sp>
-        <p:nvSpPr>
-          <p:cNvPr id="5" name="Text 3"/>
-          <p:cNvSpPr/>
-          <p:nvPr/>
-        </p:nvSpPr>
-        <p:spPr>
-          <a:xfrm>
-            <a:off x="1005840" y="1143000"/>
-            <a:ext cx="1828800" cy="274320"/>
-          </a:xfrm>
-          <a:prstGeom prst="rect">
-            <a:avLst/>
-          </a:prstGeom>
-          <a:noFill/>
-          <a:ln/>
-        </p:spPr>
-        <p:txBody>
-          <a:bodyPr wrap="square" lIns="0" tIns="0" rIns="0" bIns="0" rtlCol="0" anchor="ctr"/>
-          <a:lstStyle/>
-          <a:p>
-            <a:pPr indent="0" marL="0">
-              <a:buNone/>
-            </a:pPr>
-            <a:r>
-              <a:rPr lang="en-US" sz="1500" b="1" dirty="0">
-                <a:solidFill>
-                  <a:srgbClr val="FFFFFF"/>
-                </a:solidFill>
-                <a:latin typeface="Arial" pitchFamily="34" charset="0"/>
-                <a:ea typeface="Arial" pitchFamily="34" charset="-122"/>
-                <a:cs typeface="Arial" pitchFamily="34" charset="-120"/>
-              </a:rPr>
-              <a:t>Backend</a:t>
-            </a:r>
-            <a:endParaRPr lang="en-US" sz="1500" dirty="0"/>
-          </a:p>
-        </p:txBody>
-      </p:sp>
-      <p:sp>
-        <p:nvSpPr>
-          <p:cNvPr id="6" name="Text 4"/>
-          <p:cNvSpPr/>
-          <p:nvPr/>
-        </p:nvSpPr>
-        <p:spPr>
-          <a:xfrm>
-            <a:off x="1005840" y="1399032"/>
-            <a:ext cx="6858000" cy="228600"/>
-          </a:xfrm>
-          <a:prstGeom prst="rect">
-            <a:avLst/>
-          </a:prstGeom>
-          <a:noFill/>
-          <a:ln/>
-        </p:spPr>
-        <p:txBody>
-          <a:bodyPr wrap="square" lIns="0" tIns="0" rIns="0" bIns="0" rtlCol="0" anchor="ctr"/>
-          <a:lstStyle/>
-          <a:p>
-            <a:pPr indent="0" marL="0">
-              <a:buNone/>
-            </a:pPr>
-            <a:r>
-              <a:rPr lang="en-US" sz="1200" dirty="0">
+              <a:t>All Models Tested</a:t>
+            </a:r>
+            <a:endParaRPr lang="en-US" sz="3000" dirty="0"/>
+          </a:p>
+        </p:txBody>
+      </p:sp>
+      <p:sp>
+        <p:nvSpPr>
+          <p:cNvPr id="3" name="Text 1"/>
+          <p:cNvSpPr/>
+          <p:nvPr/>
+        </p:nvSpPr>
+        <p:spPr>
+          <a:xfrm>
+            <a:off x="640080" y="731520"/>
+            <a:ext cx="7315200" cy="274320"/>
+          </a:xfrm>
+          <a:prstGeom prst="rect">
+            <a:avLst/>
+          </a:prstGeom>
+          <a:noFill/>
+          <a:ln/>
+        </p:spPr>
+        <p:txBody>
+          <a:bodyPr wrap="square" lIns="0" tIns="0" rIns="0" bIns="0" rtlCol="0" anchor="ctr"/>
+          <a:lstStyle/>
+          <a:p>
+            <a:pPr indent="0" marL="0">
+              <a:buNone/>
+            </a:pPr>
+            <a:r>
+              <a:rPr lang="en-US" sz="1300" dirty="0">
                 <a:solidFill>
                   <a:srgbClr val="71717A"/>
                 </a:solidFill>
@@ -5702,492 +6869,36 @@
                 <a:ea typeface="Arial" pitchFamily="34" charset="-122"/>
                 <a:cs typeface="Arial" pitchFamily="34" charset="-120"/>
               </a:rPr>
-              <a:t>FastAPI + Python, scikit-learn, PyTorch</a:t>
-            </a:r>
-            <a:endParaRPr lang="en-US" sz="1200" dirty="0"/>
-          </a:p>
-        </p:txBody>
-      </p:sp>
-      <p:sp>
-        <p:nvSpPr>
-          <p:cNvPr id="7" name="Shape 5"/>
-          <p:cNvSpPr/>
-          <p:nvPr/>
-        </p:nvSpPr>
-        <p:spPr>
-          <a:xfrm>
-            <a:off x="640080" y="1828800"/>
-            <a:ext cx="7863840" cy="594360"/>
-          </a:xfrm>
-          <a:prstGeom prst="roundRect">
-            <a:avLst>
-              <a:gd name="adj" fmla="val 12308"/>
-            </a:avLst>
-          </a:prstGeom>
-          <a:solidFill>
-            <a:srgbClr val="13131A"/>
-          </a:solidFill>
-          <a:ln/>
-        </p:spPr>
-      </p:sp>
-      <p:sp>
-        <p:nvSpPr>
-          <p:cNvPr id="8" name="Shape 6"/>
-          <p:cNvSpPr/>
-          <p:nvPr/>
-        </p:nvSpPr>
-        <p:spPr>
-          <a:xfrm>
-            <a:off x="640080" y="1828800"/>
-            <a:ext cx="54864" cy="594360"/>
-          </a:xfrm>
-          <a:prstGeom prst="rect">
-            <a:avLst/>
-          </a:prstGeom>
-          <a:solidFill>
-            <a:srgbClr val="4DABF7"/>
-          </a:solidFill>
-          <a:ln/>
-        </p:spPr>
-      </p:sp>
-      <p:sp>
-        <p:nvSpPr>
-          <p:cNvPr id="9" name="Text 7"/>
-          <p:cNvSpPr/>
-          <p:nvPr/>
-        </p:nvSpPr>
-        <p:spPr>
-          <a:xfrm>
-            <a:off x="1005840" y="1874520"/>
-            <a:ext cx="1828800" cy="274320"/>
-          </a:xfrm>
-          <a:prstGeom prst="rect">
-            <a:avLst/>
-          </a:prstGeom>
-          <a:noFill/>
-          <a:ln/>
-        </p:spPr>
-        <p:txBody>
-          <a:bodyPr wrap="square" lIns="0" tIns="0" rIns="0" bIns="0" rtlCol="0" anchor="ctr"/>
-          <a:lstStyle/>
-          <a:p>
-            <a:pPr indent="0" marL="0">
-              <a:buNone/>
-            </a:pPr>
-            <a:r>
-              <a:rPr lang="en-US" sz="1500" b="1" dirty="0">
-                <a:solidFill>
-                  <a:srgbClr val="FFFFFF"/>
-                </a:solidFill>
-                <a:latin typeface="Arial" pitchFamily="34" charset="0"/>
-                <a:ea typeface="Arial" pitchFamily="34" charset="-122"/>
-                <a:cs typeface="Arial" pitchFamily="34" charset="-120"/>
-              </a:rPr>
-              <a:t>Frontend</a:t>
-            </a:r>
-            <a:endParaRPr lang="en-US" sz="1500" dirty="0"/>
-          </a:p>
-        </p:txBody>
-      </p:sp>
-      <p:sp>
-        <p:nvSpPr>
-          <p:cNvPr id="10" name="Text 8"/>
-          <p:cNvSpPr/>
-          <p:nvPr/>
-        </p:nvSpPr>
-        <p:spPr>
-          <a:xfrm>
-            <a:off x="1005840" y="2130552"/>
-            <a:ext cx="6858000" cy="228600"/>
-          </a:xfrm>
-          <a:prstGeom prst="rect">
-            <a:avLst/>
-          </a:prstGeom>
-          <a:noFill/>
-          <a:ln/>
-        </p:spPr>
-        <p:txBody>
-          <a:bodyPr wrap="square" lIns="0" tIns="0" rIns="0" bIns="0" rtlCol="0" anchor="ctr"/>
-          <a:lstStyle/>
-          <a:p>
-            <a:pPr indent="0" marL="0">
-              <a:buNone/>
-            </a:pPr>
-            <a:r>
-              <a:rPr lang="en-US" sz="1200" dirty="0">
-                <a:solidFill>
-                  <a:srgbClr val="71717A"/>
-                </a:solidFill>
-                <a:latin typeface="Arial" pitchFamily="34" charset="0"/>
-                <a:ea typeface="Arial" pitchFamily="34" charset="-122"/>
-                <a:cs typeface="Arial" pitchFamily="34" charset="-120"/>
-              </a:rPr>
-              <a:t>Next.js 14, React 18, TailwindCSS</a:t>
-            </a:r>
-            <a:endParaRPr lang="en-US" sz="1200" dirty="0"/>
-          </a:p>
-        </p:txBody>
-      </p:sp>
-      <p:sp>
-        <p:nvSpPr>
-          <p:cNvPr id="11" name="Shape 9"/>
-          <p:cNvSpPr/>
-          <p:nvPr/>
-        </p:nvSpPr>
-        <p:spPr>
-          <a:xfrm>
-            <a:off x="640080" y="2560320"/>
-            <a:ext cx="7863840" cy="594360"/>
-          </a:xfrm>
-          <a:prstGeom prst="roundRect">
-            <a:avLst>
-              <a:gd name="adj" fmla="val 12308"/>
-            </a:avLst>
-          </a:prstGeom>
-          <a:solidFill>
-            <a:srgbClr val="13131A"/>
-          </a:solidFill>
-          <a:ln/>
-        </p:spPr>
-      </p:sp>
-      <p:sp>
-        <p:nvSpPr>
-          <p:cNvPr id="12" name="Shape 10"/>
-          <p:cNvSpPr/>
-          <p:nvPr/>
-        </p:nvSpPr>
-        <p:spPr>
-          <a:xfrm>
-            <a:off x="640080" y="2560320"/>
-            <a:ext cx="54864" cy="594360"/>
-          </a:xfrm>
-          <a:prstGeom prst="rect">
-            <a:avLst/>
-          </a:prstGeom>
-          <a:solidFill>
-            <a:srgbClr val="6C5CE7"/>
-          </a:solidFill>
-          <a:ln/>
-        </p:spPr>
-      </p:sp>
-      <p:sp>
-        <p:nvSpPr>
-          <p:cNvPr id="13" name="Text 11"/>
-          <p:cNvSpPr/>
-          <p:nvPr/>
-        </p:nvSpPr>
-        <p:spPr>
-          <a:xfrm>
-            <a:off x="1005840" y="2606040"/>
-            <a:ext cx="1828800" cy="274320"/>
-          </a:xfrm>
-          <a:prstGeom prst="rect">
-            <a:avLst/>
-          </a:prstGeom>
-          <a:noFill/>
-          <a:ln/>
-        </p:spPr>
-        <p:txBody>
-          <a:bodyPr wrap="square" lIns="0" tIns="0" rIns="0" bIns="0" rtlCol="0" anchor="ctr"/>
-          <a:lstStyle/>
-          <a:p>
-            <a:pPr indent="0" marL="0">
-              <a:buNone/>
-            </a:pPr>
-            <a:r>
-              <a:rPr lang="en-US" sz="1500" b="1" dirty="0">
-                <a:solidFill>
-                  <a:srgbClr val="FFFFFF"/>
-                </a:solidFill>
-                <a:latin typeface="Arial" pitchFamily="34" charset="0"/>
-                <a:ea typeface="Arial" pitchFamily="34" charset="-122"/>
-                <a:cs typeface="Arial" pitchFamily="34" charset="-120"/>
-              </a:rPr>
-              <a:t>Data</a:t>
-            </a:r>
-            <a:endParaRPr lang="en-US" sz="1500" dirty="0"/>
-          </a:p>
-        </p:txBody>
-      </p:sp>
-      <p:sp>
-        <p:nvSpPr>
-          <p:cNvPr id="14" name="Text 12"/>
-          <p:cNvSpPr/>
-          <p:nvPr/>
-        </p:nvSpPr>
-        <p:spPr>
-          <a:xfrm>
-            <a:off x="1005840" y="2862072"/>
-            <a:ext cx="6858000" cy="228600"/>
-          </a:xfrm>
-          <a:prstGeom prst="rect">
-            <a:avLst/>
-          </a:prstGeom>
-          <a:noFill/>
-          <a:ln/>
-        </p:spPr>
-        <p:txBody>
-          <a:bodyPr wrap="square" lIns="0" tIns="0" rIns="0" bIns="0" rtlCol="0" anchor="ctr"/>
-          <a:lstStyle/>
-          <a:p>
-            <a:pPr indent="0" marL="0">
-              <a:buNone/>
-            </a:pPr>
-            <a:r>
-              <a:rPr lang="en-US" sz="1200" dirty="0">
-                <a:solidFill>
-                  <a:srgbClr val="71717A"/>
-                </a:solidFill>
-                <a:latin typeface="Arial" pitchFamily="34" charset="0"/>
-                <a:ea typeface="Arial" pitchFamily="34" charset="-122"/>
-                <a:cs typeface="Arial" pitchFamily="34" charset="-120"/>
-              </a:rPr>
-              <a:t>BGeometrics Premium, Binance.US, Coinbase, Polymarket</a:t>
-            </a:r>
-            <a:endParaRPr lang="en-US" sz="1200" dirty="0"/>
-          </a:p>
-        </p:txBody>
-      </p:sp>
-      <p:sp>
-        <p:nvSpPr>
-          <p:cNvPr id="15" name="Shape 13"/>
-          <p:cNvSpPr/>
-          <p:nvPr/>
-        </p:nvSpPr>
-        <p:spPr>
-          <a:xfrm>
-            <a:off x="640080" y="3291840"/>
-            <a:ext cx="7863840" cy="594360"/>
-          </a:xfrm>
-          <a:prstGeom prst="roundRect">
-            <a:avLst>
-              <a:gd name="adj" fmla="val 12308"/>
-            </a:avLst>
-          </a:prstGeom>
-          <a:solidFill>
-            <a:srgbClr val="13131A"/>
-          </a:solidFill>
-          <a:ln/>
-        </p:spPr>
-      </p:sp>
-      <p:sp>
-        <p:nvSpPr>
-          <p:cNvPr id="16" name="Shape 14"/>
-          <p:cNvSpPr/>
-          <p:nvPr/>
-        </p:nvSpPr>
-        <p:spPr>
-          <a:xfrm>
-            <a:off x="640080" y="3291840"/>
-            <a:ext cx="54864" cy="594360"/>
-          </a:xfrm>
-          <a:prstGeom prst="rect">
-            <a:avLst/>
-          </a:prstGeom>
-          <a:solidFill>
-            <a:srgbClr val="FFD93D"/>
-          </a:solidFill>
-          <a:ln/>
-        </p:spPr>
-      </p:sp>
-      <p:sp>
-        <p:nvSpPr>
-          <p:cNvPr id="17" name="Text 15"/>
-          <p:cNvSpPr/>
-          <p:nvPr/>
-        </p:nvSpPr>
-        <p:spPr>
-          <a:xfrm>
-            <a:off x="1005840" y="3337560"/>
-            <a:ext cx="1828800" cy="274320"/>
-          </a:xfrm>
-          <a:prstGeom prst="rect">
-            <a:avLst/>
-          </a:prstGeom>
-          <a:noFill/>
-          <a:ln/>
-        </p:spPr>
-        <p:txBody>
-          <a:bodyPr wrap="square" lIns="0" tIns="0" rIns="0" bIns="0" rtlCol="0" anchor="ctr"/>
-          <a:lstStyle/>
-          <a:p>
-            <a:pPr indent="0" marL="0">
-              <a:buNone/>
-            </a:pPr>
-            <a:r>
-              <a:rPr lang="en-US" sz="1500" b="1" dirty="0">
-                <a:solidFill>
-                  <a:srgbClr val="FFFFFF"/>
-                </a:solidFill>
-                <a:latin typeface="Arial" pitchFamily="34" charset="0"/>
-                <a:ea typeface="Arial" pitchFamily="34" charset="-122"/>
-                <a:cs typeface="Arial" pitchFamily="34" charset="-120"/>
-              </a:rPr>
-              <a:t>Price</a:t>
-            </a:r>
-            <a:endParaRPr lang="en-US" sz="1500" dirty="0"/>
-          </a:p>
-        </p:txBody>
-      </p:sp>
-      <p:sp>
-        <p:nvSpPr>
-          <p:cNvPr id="18" name="Text 16"/>
-          <p:cNvSpPr/>
-          <p:nvPr/>
-        </p:nvSpPr>
-        <p:spPr>
-          <a:xfrm>
-            <a:off x="1005840" y="3593592"/>
-            <a:ext cx="6858000" cy="228600"/>
-          </a:xfrm>
-          <a:prstGeom prst="rect">
-            <a:avLst/>
-          </a:prstGeom>
-          <a:noFill/>
-          <a:ln/>
-        </p:spPr>
-        <p:txBody>
-          <a:bodyPr wrap="square" lIns="0" tIns="0" rIns="0" bIns="0" rtlCol="0" anchor="ctr"/>
-          <a:lstStyle/>
-          <a:p>
-            <a:pPr indent="0" marL="0">
-              <a:buNone/>
-            </a:pPr>
-            <a:r>
-              <a:rPr lang="en-US" sz="1200" dirty="0">
-                <a:solidFill>
-                  <a:srgbClr val="71717A"/>
-                </a:solidFill>
-                <a:latin typeface="Arial" pitchFamily="34" charset="0"/>
-                <a:ea typeface="Arial" pitchFamily="34" charset="-122"/>
-                <a:cs typeface="Arial" pitchFamily="34" charset="-120"/>
-              </a:rPr>
-              <a:t>TrueMarkets MCP (same source everywhere)</a:t>
-            </a:r>
-            <a:endParaRPr lang="en-US" sz="1200" dirty="0"/>
-          </a:p>
-        </p:txBody>
-      </p:sp>
-      <p:sp>
-        <p:nvSpPr>
-          <p:cNvPr id="19" name="Shape 17"/>
-          <p:cNvSpPr/>
-          <p:nvPr/>
-        </p:nvSpPr>
-        <p:spPr>
-          <a:xfrm>
-            <a:off x="640080" y="4023360"/>
-            <a:ext cx="7863840" cy="594360"/>
-          </a:xfrm>
-          <a:prstGeom prst="roundRect">
-            <a:avLst>
-              <a:gd name="adj" fmla="val 12308"/>
-            </a:avLst>
-          </a:prstGeom>
-          <a:solidFill>
-            <a:srgbClr val="13131A"/>
-          </a:solidFill>
-          <a:ln/>
-        </p:spPr>
-      </p:sp>
-      <p:sp>
-        <p:nvSpPr>
-          <p:cNvPr id="20" name="Shape 18"/>
-          <p:cNvSpPr/>
-          <p:nvPr/>
-        </p:nvSpPr>
-        <p:spPr>
-          <a:xfrm>
-            <a:off x="640080" y="4023360"/>
-            <a:ext cx="54864" cy="594360"/>
-          </a:xfrm>
-          <a:prstGeom prst="rect">
-            <a:avLst/>
-          </a:prstGeom>
-          <a:solidFill>
-            <a:srgbClr val="FF6B6B"/>
-          </a:solidFill>
-          <a:ln/>
-        </p:spPr>
-      </p:sp>
-      <p:sp>
-        <p:nvSpPr>
-          <p:cNvPr id="21" name="Text 19"/>
-          <p:cNvSpPr/>
-          <p:nvPr/>
-        </p:nvSpPr>
-        <p:spPr>
-          <a:xfrm>
-            <a:off x="1005840" y="4069080"/>
-            <a:ext cx="1828800" cy="274320"/>
-          </a:xfrm>
-          <a:prstGeom prst="rect">
-            <a:avLst/>
-          </a:prstGeom>
-          <a:noFill/>
-          <a:ln/>
-        </p:spPr>
-        <p:txBody>
-          <a:bodyPr wrap="square" lIns="0" tIns="0" rIns="0" bIns="0" rtlCol="0" anchor="ctr"/>
-          <a:lstStyle/>
-          <a:p>
-            <a:pPr indent="0" marL="0">
-              <a:buNone/>
-            </a:pPr>
-            <a:r>
-              <a:rPr lang="en-US" sz="1500" b="1" dirty="0">
-                <a:solidFill>
-                  <a:srgbClr val="FFFFFF"/>
-                </a:solidFill>
-                <a:latin typeface="Arial" pitchFamily="34" charset="0"/>
-                <a:ea typeface="Arial" pitchFamily="34" charset="-122"/>
-                <a:cs typeface="Arial" pitchFamily="34" charset="-120"/>
-              </a:rPr>
-              <a:t>Refresh</a:t>
-            </a:r>
-            <a:endParaRPr lang="en-US" sz="1500" dirty="0"/>
-          </a:p>
-        </p:txBody>
-      </p:sp>
-      <p:sp>
-        <p:nvSpPr>
-          <p:cNvPr id="22" name="Text 20"/>
-          <p:cNvSpPr/>
-          <p:nvPr/>
-        </p:nvSpPr>
-        <p:spPr>
-          <a:xfrm>
-            <a:off x="1005840" y="4325112"/>
-            <a:ext cx="6858000" cy="228600"/>
-          </a:xfrm>
-          <a:prstGeom prst="rect">
-            <a:avLst/>
-          </a:prstGeom>
-          <a:noFill/>
-          <a:ln/>
-        </p:spPr>
-        <p:txBody>
-          <a:bodyPr wrap="square" lIns="0" tIns="0" rIns="0" bIns="0" rtlCol="0" anchor="ctr"/>
-          <a:lstStyle/>
-          <a:p>
-            <a:pPr indent="0" marL="0">
-              <a:buNone/>
-            </a:pPr>
-            <a:r>
-              <a:rPr lang="en-US" sz="1200" dirty="0">
-                <a:solidFill>
-                  <a:srgbClr val="71717A"/>
-                </a:solidFill>
-                <a:latin typeface="Arial" pitchFamily="34" charset="0"/>
-                <a:ea typeface="Arial" pitchFamily="34" charset="-122"/>
-                <a:cs typeface="Arial" pitchFamily="34" charset="-120"/>
-              </a:rPr>
-              <a:t>30 seconds, all 6 signals</a:t>
-            </a:r>
-            <a:endParaRPr lang="en-US" sz="1200" dirty="0"/>
-          </a:p>
-        </p:txBody>
-      </p:sp>
+              <a:t>12 model configurations compared on OOS BTC direction prediction</a:t>
+            </a:r>
+            <a:endParaRPr lang="en-US" sz="1300" dirty="0"/>
+          </a:p>
+        </p:txBody>
+      </p:sp>
+      <p:pic>
+        <p:nvPicPr>
+          <p:cNvPr id="4" name="Image 0" descr="preencoded.png">    </p:cNvPr>
+          <p:cNvPicPr>
+            <a:picLocks noChangeAspect="1"/>
+          </p:cNvPicPr>
+          <p:nvPr/>
+        </p:nvPicPr>
+        <p:blipFill>
+          <a:blip r:embed="rId1"/>
+          <a:stretch>
+            <a:fillRect/>
+          </a:stretch>
+        </p:blipFill>
+        <p:spPr>
+          <a:xfrm>
+            <a:off x="182880" y="1005840"/>
+            <a:ext cx="8778240" cy="3931920"/>
+          </a:xfrm>
+          <a:prstGeom prst="rect">
+            <a:avLst/>
+          </a:prstGeom>
+        </p:spPr>
+      </p:pic>
     </p:spTree>
   </p:cSld>
   <p:clrMapOvr>
@@ -6228,7 +6939,7 @@
         </p:nvSpPr>
         <p:spPr>
           <a:xfrm>
-            <a:off x="640080" y="365760"/>
+            <a:off x="640080" y="274320"/>
             <a:ext cx="7315200" cy="548640"/>
           </a:xfrm>
           <a:prstGeom prst="rect">
@@ -6245,7 +6956,7 @@
               <a:buNone/>
             </a:pPr>
             <a:r>
-              <a:rPr lang="en-US" sz="3600" b="1" dirty="0">
+              <a:rPr lang="en-US" sz="3200" b="1" dirty="0">
                 <a:solidFill>
                   <a:srgbClr val="FFFFFF"/>
                 </a:solidFill>
@@ -6253,9 +6964,9 @@
                 <a:ea typeface="Arial Black" pitchFamily="34" charset="-122"/>
                 <a:cs typeface="Arial Black" pitchFamily="34" charset="-120"/>
               </a:rPr>
-              <a:t>The Product</a:t>
-            </a:r>
-            <a:endParaRPr lang="en-US" sz="3600" dirty="0"/>
+              <a:t>Where It Goes From Here</a:t>
+            </a:r>
+            <a:endParaRPr lang="en-US" sz="3200" dirty="0"/>
           </a:p>
         </p:txBody>
       </p:sp>
@@ -6267,12 +6978,12 @@
         </p:nvSpPr>
         <p:spPr>
           <a:xfrm>
-            <a:off x="640080" y="1097280"/>
-            <a:ext cx="3749040" cy="3474720"/>
+            <a:off x="640080" y="1005840"/>
+            <a:ext cx="3931920" cy="3840480"/>
           </a:xfrm>
           <a:prstGeom prst="roundRect">
             <a:avLst>
-              <a:gd name="adj" fmla="val 2632"/>
+              <a:gd name="adj" fmla="val 2381"/>
             </a:avLst>
           </a:prstGeom>
           <a:solidFill>
@@ -6289,24 +7000,24 @@
         </p:nvSpPr>
         <p:spPr>
           <a:xfrm>
-            <a:off x="822960" y="1188720"/>
-            <a:ext cx="3200400" cy="365760"/>
-          </a:xfrm>
-          <a:prstGeom prst="rect">
-            <a:avLst/>
-          </a:prstGeom>
-          <a:noFill/>
-          <a:ln/>
-        </p:spPr>
-        <p:txBody>
-          <a:bodyPr wrap="square" lIns="0" tIns="0" rIns="0" bIns="0" rtlCol="0" anchor="ctr"/>
-          <a:lstStyle/>
-          <a:p>
-            <a:pPr indent="0" marL="0">
-              <a:buNone/>
-            </a:pPr>
-            <a:r>
-              <a:rPr lang="en-US" sz="1800" b="1" dirty="0">
+            <a:off x="822960" y="1097280"/>
+            <a:ext cx="3200400" cy="320040"/>
+          </a:xfrm>
+          <a:prstGeom prst="rect">
+            <a:avLst/>
+          </a:prstGeom>
+          <a:noFill/>
+          <a:ln/>
+        </p:spPr>
+        <p:txBody>
+          <a:bodyPr wrap="square" lIns="0" tIns="0" rIns="0" bIns="0" rtlCol="0" anchor="ctr"/>
+          <a:lstStyle/>
+          <a:p>
+            <a:pPr indent="0" marL="0">
+              <a:buNone/>
+            </a:pPr>
+            <a:r>
+              <a:rPr lang="en-US" sz="1600" b="1" dirty="0">
                 <a:solidFill>
                   <a:srgbClr val="00D4AA"/>
                 </a:solidFill>
@@ -6314,101 +7025,360 @@
                 <a:ea typeface="Arial" pitchFamily="34" charset="-122"/>
                 <a:cs typeface="Arial" pitchFamily="34" charset="-120"/>
               </a:rPr>
-              <a:t>Market Page</a:t>
-            </a:r>
-            <a:endParaRPr lang="en-US" sz="1800" dirty="0"/>
-          </a:p>
-        </p:txBody>
-      </p:sp>
-      <p:sp>
-        <p:nvSpPr>
-          <p:cNvPr id="5" name="Text 3"/>
-          <p:cNvSpPr/>
-          <p:nvPr/>
-        </p:nvSpPr>
-        <p:spPr>
-          <a:xfrm>
-            <a:off x="822960" y="1645920"/>
-            <a:ext cx="3383280" cy="2286000"/>
-          </a:xfrm>
-          <a:prstGeom prst="rect">
-            <a:avLst/>
-          </a:prstGeom>
-          <a:noFill/>
-          <a:ln/>
-        </p:spPr>
-        <p:txBody>
-          <a:bodyPr wrap="square" rtlCol="0" anchor="ctr"/>
-          <a:lstStyle/>
-          <a:p>
-            <a:pPr marL="342900" indent="-342900">
-              <a:buSzPct val="100000"/>
-              <a:buChar char="•"/>
-            </a:pPr>
-            <a:r>
-              <a:rPr lang="en-US" sz="1200" dirty="0">
-                <a:solidFill>
-                  <a:srgbClr val="E4E4E7"/>
-                </a:solidFill>
-                <a:latin typeface="Arial" pitchFamily="34" charset="0"/>
-                <a:ea typeface="Arial" pitchFamily="34" charset="-122"/>
-                <a:cs typeface="Arial" pitchFamily="34" charset="-120"/>
-              </a:rPr>
-              <a:t>Live BTC price + chart</a:t>
+              <a:t>Next Steps</a:t>
+            </a:r>
+            <a:endParaRPr lang="en-US" sz="1600" dirty="0"/>
+          </a:p>
+        </p:txBody>
+      </p:sp>
+      <p:sp>
+        <p:nvSpPr>
+          <p:cNvPr id="5" name="Shape 3"/>
+          <p:cNvSpPr/>
+          <p:nvPr/>
+        </p:nvSpPr>
+        <p:spPr>
+          <a:xfrm>
+            <a:off x="868680" y="1554480"/>
+            <a:ext cx="137160" cy="137160"/>
+          </a:xfrm>
+          <a:prstGeom prst="ellipse">
+            <a:avLst/>
+          </a:prstGeom>
+          <a:solidFill>
+            <a:srgbClr val="00D4AA"/>
+          </a:solidFill>
+          <a:ln/>
+        </p:spPr>
+      </p:sp>
+      <p:sp>
+        <p:nvSpPr>
+          <p:cNvPr id="6" name="Text 4"/>
+          <p:cNvSpPr/>
+          <p:nvPr/>
+        </p:nvSpPr>
+        <p:spPr>
+          <a:xfrm>
+            <a:off x="1143000" y="1508760"/>
+            <a:ext cx="3200400" cy="228600"/>
+          </a:xfrm>
+          <a:prstGeom prst="rect">
+            <a:avLst/>
+          </a:prstGeom>
+          <a:noFill/>
+          <a:ln/>
+        </p:spPr>
+        <p:txBody>
+          <a:bodyPr wrap="square" lIns="0" tIns="0" rIns="0" bIns="0" rtlCol="0" anchor="ctr"/>
+          <a:lstStyle/>
+          <a:p>
+            <a:pPr indent="0" marL="0">
+              <a:buNone/>
+            </a:pPr>
+            <a:r>
+              <a:rPr lang="en-US" sz="1200" b="1" dirty="0">
+                <a:solidFill>
+                  <a:srgbClr val="FFFFFF"/>
+                </a:solidFill>
+                <a:latin typeface="Arial" pitchFamily="34" charset="0"/>
+                <a:ea typeface="Arial" pitchFamily="34" charset="-122"/>
+                <a:cs typeface="Arial" pitchFamily="34" charset="-120"/>
+              </a:rPr>
+              <a:t>Glassnode Pro (87 features)</a:t>
             </a:r>
             <a:endParaRPr lang="en-US" sz="1200" dirty="0"/>
           </a:p>
-          <a:p>
-            <a:pPr marL="342900" indent="-342900">
-              <a:buSzPct val="100000"/>
-              <a:buChar char="•"/>
-            </a:pPr>
-            <a:r>
-              <a:rPr lang="en-US" sz="1200" dirty="0">
-                <a:solidFill>
-                  <a:srgbClr val="E4E4E7"/>
-                </a:solidFill>
-                <a:latin typeface="Arial" pitchFamily="34" charset="0"/>
-                <a:ea typeface="Arial" pitchFamily="34" charset="-122"/>
-                <a:cs typeface="Arial" pitchFamily="34" charset="-120"/>
-              </a:rPr>
-              <a:t>Market cap, volume, highs/lows</a:t>
+        </p:txBody>
+      </p:sp>
+      <p:sp>
+        <p:nvSpPr>
+          <p:cNvPr id="7" name="Text 5"/>
+          <p:cNvSpPr/>
+          <p:nvPr/>
+        </p:nvSpPr>
+        <p:spPr>
+          <a:xfrm>
+            <a:off x="1143000" y="1764792"/>
+            <a:ext cx="3200400" cy="457200"/>
+          </a:xfrm>
+          <a:prstGeom prst="rect">
+            <a:avLst/>
+          </a:prstGeom>
+          <a:noFill/>
+          <a:ln/>
+        </p:spPr>
+        <p:txBody>
+          <a:bodyPr wrap="square" lIns="0" tIns="0" rIns="0" bIns="0" rtlCol="0" anchor="ctr"/>
+          <a:lstStyle/>
+          <a:p>
+            <a:pPr indent="0" marL="0">
+              <a:buNone/>
+            </a:pPr>
+            <a:r>
+              <a:rPr lang="en-US" sz="1000" dirty="0">
+                <a:solidFill>
+                  <a:srgbClr val="71717A"/>
+                </a:solidFill>
+                <a:latin typeface="Arial" pitchFamily="34" charset="0"/>
+                <a:ea typeface="Arial" pitchFamily="34" charset="-122"/>
+                <a:cs typeface="Arial" pitchFamily="34" charset="-120"/>
+              </a:rPr>
+              <a:t>Paper achieves 82.44% with full Glassnode data. We have 42 features from BGeometrics. More data = higher accuracy.</a:t>
+            </a:r>
+            <a:endParaRPr lang="en-US" sz="1000" dirty="0"/>
+          </a:p>
+        </p:txBody>
+      </p:sp>
+      <p:sp>
+        <p:nvSpPr>
+          <p:cNvPr id="8" name="Shape 6"/>
+          <p:cNvSpPr/>
+          <p:nvPr/>
+        </p:nvSpPr>
+        <p:spPr>
+          <a:xfrm>
+            <a:off x="868680" y="2331720"/>
+            <a:ext cx="137160" cy="137160"/>
+          </a:xfrm>
+          <a:prstGeom prst="ellipse">
+            <a:avLst/>
+          </a:prstGeom>
+          <a:solidFill>
+            <a:srgbClr val="6C5CE7"/>
+          </a:solidFill>
+          <a:ln/>
+        </p:spPr>
+      </p:sp>
+      <p:sp>
+        <p:nvSpPr>
+          <p:cNvPr id="9" name="Text 7"/>
+          <p:cNvSpPr/>
+          <p:nvPr/>
+        </p:nvSpPr>
+        <p:spPr>
+          <a:xfrm>
+            <a:off x="1143000" y="2286000"/>
+            <a:ext cx="3200400" cy="228600"/>
+          </a:xfrm>
+          <a:prstGeom prst="rect">
+            <a:avLst/>
+          </a:prstGeom>
+          <a:noFill/>
+          <a:ln/>
+        </p:spPr>
+        <p:txBody>
+          <a:bodyPr wrap="square" lIns="0" tIns="0" rIns="0" bIns="0" rtlCol="0" anchor="ctr"/>
+          <a:lstStyle/>
+          <a:p>
+            <a:pPr indent="0" marL="0">
+              <a:buNone/>
+            </a:pPr>
+            <a:r>
+              <a:rPr lang="en-US" sz="1200" b="1" dirty="0">
+                <a:solidFill>
+                  <a:srgbClr val="FFFFFF"/>
+                </a:solidFill>
+                <a:latin typeface="Arial" pitchFamily="34" charset="0"/>
+                <a:ea typeface="Arial" pitchFamily="34" charset="-122"/>
+                <a:cs typeface="Arial" pitchFamily="34" charset="-120"/>
+              </a:rPr>
+              <a:t>CNN-LSTM architecture</a:t>
             </a:r>
             <a:endParaRPr lang="en-US" sz="1200" dirty="0"/>
           </a:p>
-          <a:p>
-            <a:pPr marL="342900" indent="-342900">
-              <a:buSzPct val="100000"/>
-              <a:buChar char="•"/>
-            </a:pPr>
-            <a:r>
-              <a:rPr lang="en-US" sz="1200" dirty="0">
-                <a:solidFill>
-                  <a:srgbClr val="E4E4E7"/>
-                </a:solidFill>
-                <a:latin typeface="Arial" pitchFamily="34" charset="0"/>
-                <a:ea typeface="Arial" pitchFamily="34" charset="-122"/>
-                <a:cs typeface="Arial" pitchFamily="34" charset="-120"/>
-              </a:rPr>
-              <a:t>Fear &amp; Greed Index</a:t>
+        </p:txBody>
+      </p:sp>
+      <p:sp>
+        <p:nvSpPr>
+          <p:cNvPr id="10" name="Text 8"/>
+          <p:cNvSpPr/>
+          <p:nvPr/>
+        </p:nvSpPr>
+        <p:spPr>
+          <a:xfrm>
+            <a:off x="1143000" y="2542032"/>
+            <a:ext cx="3200400" cy="457200"/>
+          </a:xfrm>
+          <a:prstGeom prst="rect">
+            <a:avLst/>
+          </a:prstGeom>
+          <a:noFill/>
+          <a:ln/>
+        </p:spPr>
+        <p:txBody>
+          <a:bodyPr wrap="square" lIns="0" tIns="0" rIns="0" bIns="0" rtlCol="0" anchor="ctr"/>
+          <a:lstStyle/>
+          <a:p>
+            <a:pPr indent="0" marL="0">
+              <a:buNone/>
+            </a:pPr>
+            <a:r>
+              <a:rPr lang="en-US" sz="1000" dirty="0">
+                <a:solidFill>
+                  <a:srgbClr val="71717A"/>
+                </a:solidFill>
+                <a:latin typeface="Arial" pitchFamily="34" charset="0"/>
+                <a:ea typeface="Arial" pitchFamily="34" charset="-122"/>
+                <a:cs typeface="Arial" pitchFamily="34" charset="-120"/>
+              </a:rPr>
+              <a:t>Omole &amp; Enke 2024 CNN-LSTM with 87 Glassnode features reached 82.44%. Our GradientBoosting at 67.4% is limited by data, not architecture.</a:t>
+            </a:r>
+            <a:endParaRPr lang="en-US" sz="1000" dirty="0"/>
+          </a:p>
+        </p:txBody>
+      </p:sp>
+      <p:sp>
+        <p:nvSpPr>
+          <p:cNvPr id="11" name="Shape 9"/>
+          <p:cNvSpPr/>
+          <p:nvPr/>
+        </p:nvSpPr>
+        <p:spPr>
+          <a:xfrm>
+            <a:off x="868680" y="3108960"/>
+            <a:ext cx="137160" cy="137160"/>
+          </a:xfrm>
+          <a:prstGeom prst="ellipse">
+            <a:avLst/>
+          </a:prstGeom>
+          <a:solidFill>
+            <a:srgbClr val="4DABF7"/>
+          </a:solidFill>
+          <a:ln/>
+        </p:spPr>
+      </p:sp>
+      <p:sp>
+        <p:nvSpPr>
+          <p:cNvPr id="12" name="Text 10"/>
+          <p:cNvSpPr/>
+          <p:nvPr/>
+        </p:nvSpPr>
+        <p:spPr>
+          <a:xfrm>
+            <a:off x="1143000" y="3063240"/>
+            <a:ext cx="3200400" cy="228600"/>
+          </a:xfrm>
+          <a:prstGeom prst="rect">
+            <a:avLst/>
+          </a:prstGeom>
+          <a:noFill/>
+          <a:ln/>
+        </p:spPr>
+        <p:txBody>
+          <a:bodyPr wrap="square" lIns="0" tIns="0" rIns="0" bIns="0" rtlCol="0" anchor="ctr"/>
+          <a:lstStyle/>
+          <a:p>
+            <a:pPr indent="0" marL="0">
+              <a:buNone/>
+            </a:pPr>
+            <a:r>
+              <a:rPr lang="en-US" sz="1200" b="1" dirty="0">
+                <a:solidFill>
+                  <a:srgbClr val="FFFFFF"/>
+                </a:solidFill>
+                <a:latin typeface="Arial" pitchFamily="34" charset="0"/>
+                <a:ea typeface="Arial" pitchFamily="34" charset="-122"/>
+                <a:cs typeface="Arial" pitchFamily="34" charset="-120"/>
+              </a:rPr>
+              <a:t>Expand to ETH, SOL</a:t>
             </a:r>
             <a:endParaRPr lang="en-US" sz="1200" dirty="0"/>
           </a:p>
-          <a:p>
-            <a:pPr marL="342900" indent="-342900">
-              <a:buSzPct val="100000"/>
-              <a:buChar char="•"/>
-            </a:pPr>
-            <a:r>
-              <a:rPr lang="en-US" sz="1200" dirty="0">
-                <a:solidFill>
-                  <a:srgbClr val="E4E4E7"/>
-                </a:solidFill>
-                <a:latin typeface="Arial" pitchFamily="34" charset="0"/>
-                <a:ea typeface="Arial" pitchFamily="34" charset="-122"/>
-                <a:cs typeface="Arial" pitchFamily="34" charset="-120"/>
-              </a:rPr>
-              <a:t>TM Sentiment (30+ sources)</a:t>
+        </p:txBody>
+      </p:sp>
+      <p:sp>
+        <p:nvSpPr>
+          <p:cNvPr id="13" name="Text 11"/>
+          <p:cNvSpPr/>
+          <p:nvPr/>
+        </p:nvSpPr>
+        <p:spPr>
+          <a:xfrm>
+            <a:off x="1143000" y="3319272"/>
+            <a:ext cx="3200400" cy="457200"/>
+          </a:xfrm>
+          <a:prstGeom prst="rect">
+            <a:avLst/>
+          </a:prstGeom>
+          <a:noFill/>
+          <a:ln/>
+        </p:spPr>
+        <p:txBody>
+          <a:bodyPr wrap="square" lIns="0" tIns="0" rIns="0" bIns="0" rtlCol="0" anchor="ctr"/>
+          <a:lstStyle/>
+          <a:p>
+            <a:pPr indent="0" marL="0">
+              <a:buNone/>
+            </a:pPr>
+            <a:r>
+              <a:rPr lang="en-US" sz="1000" dirty="0">
+                <a:solidFill>
+                  <a:srgbClr val="71717A"/>
+                </a:solidFill>
+                <a:latin typeface="Arial" pitchFamily="34" charset="0"/>
+                <a:ea typeface="Arial" pitchFamily="34" charset="-122"/>
+                <a:cs typeface="Arial" pitchFamily="34" charset="-120"/>
+              </a:rPr>
+              <a:t>Same 6-signal architecture per coin. BGeometrics supports ETH on-chain. Polymarket has ETH/SOL markets.</a:t>
+            </a:r>
+            <a:endParaRPr lang="en-US" sz="1000" dirty="0"/>
+          </a:p>
+        </p:txBody>
+      </p:sp>
+      <p:sp>
+        <p:nvSpPr>
+          <p:cNvPr id="14" name="Shape 12"/>
+          <p:cNvSpPr/>
+          <p:nvPr/>
+        </p:nvSpPr>
+        <p:spPr>
+          <a:xfrm>
+            <a:off x="868680" y="3886200"/>
+            <a:ext cx="137160" cy="137160"/>
+          </a:xfrm>
+          <a:prstGeom prst="ellipse">
+            <a:avLst/>
+          </a:prstGeom>
+          <a:solidFill>
+            <a:srgbClr val="FFD93D"/>
+          </a:solidFill>
+          <a:ln/>
+        </p:spPr>
+      </p:sp>
+      <p:sp>
+        <p:nvSpPr>
+          <p:cNvPr id="15" name="Text 13"/>
+          <p:cNvSpPr/>
+          <p:nvPr/>
+        </p:nvSpPr>
+        <p:spPr>
+          <a:xfrm>
+            <a:off x="1143000" y="3840480"/>
+            <a:ext cx="3200400" cy="228600"/>
+          </a:xfrm>
+          <a:prstGeom prst="rect">
+            <a:avLst/>
+          </a:prstGeom>
+          <a:noFill/>
+          <a:ln/>
+        </p:spPr>
+        <p:txBody>
+          <a:bodyPr wrap="square" lIns="0" tIns="0" rIns="0" bIns="0" rtlCol="0" anchor="ctr"/>
+          <a:lstStyle/>
+          <a:p>
+            <a:pPr indent="0" marL="0">
+              <a:buNone/>
+            </a:pPr>
+            <a:r>
+              <a:rPr lang="en-US" sz="1200" b="1" dirty="0">
+                <a:solidFill>
+                  <a:srgbClr val="FFFFFF"/>
+                </a:solidFill>
+                <a:latin typeface="Arial" pitchFamily="34" charset="0"/>
+                <a:ea typeface="Arial" pitchFamily="34" charset="-122"/>
+                <a:cs typeface="Arial" pitchFamily="34" charset="-120"/>
+              </a:rPr>
+              <a:t>Hourly predictions</a:t>
             </a:r>
             <a:endParaRPr lang="en-US" sz="1200" dirty="0"/>
           </a:p>
@@ -6416,18 +7386,57 @@
       </p:sp>
       <p:sp>
         <p:nvSpPr>
-          <p:cNvPr id="6" name="Shape 4"/>
-          <p:cNvSpPr/>
-          <p:nvPr/>
-        </p:nvSpPr>
-        <p:spPr>
-          <a:xfrm>
-            <a:off x="4754880" y="1097280"/>
-            <a:ext cx="3931920" cy="3474720"/>
+          <p:cNvPr id="16" name="Text 14"/>
+          <p:cNvSpPr/>
+          <p:nvPr/>
+        </p:nvSpPr>
+        <p:spPr>
+          <a:xfrm>
+            <a:off x="1143000" y="4096512"/>
+            <a:ext cx="3200400" cy="457200"/>
+          </a:xfrm>
+          <a:prstGeom prst="rect">
+            <a:avLst/>
+          </a:prstGeom>
+          <a:noFill/>
+          <a:ln/>
+        </p:spPr>
+        <p:txBody>
+          <a:bodyPr wrap="square" lIns="0" tIns="0" rIns="0" bIns="0" rtlCol="0" anchor="ctr"/>
+          <a:lstStyle/>
+          <a:p>
+            <a:pPr indent="0" marL="0">
+              <a:buNone/>
+            </a:pPr>
+            <a:r>
+              <a:rPr lang="en-US" sz="1000" dirty="0">
+                <a:solidFill>
+                  <a:srgbClr val="71717A"/>
+                </a:solidFill>
+                <a:latin typeface="Arial" pitchFamily="34" charset="0"/>
+                <a:ea typeface="Arial" pitchFamily="34" charset="-122"/>
+                <a:cs typeface="Arial" pitchFamily="34" charset="-120"/>
+              </a:rPr>
+              <a:t>Currently daily. With Glassnode hourly data, can predict intraday moves for higher-frequency trading.</a:t>
+            </a:r>
+            <a:endParaRPr lang="en-US" sz="1000" dirty="0"/>
+          </a:p>
+        </p:txBody>
+      </p:sp>
+      <p:sp>
+        <p:nvSpPr>
+          <p:cNvPr id="17" name="Shape 15"/>
+          <p:cNvSpPr/>
+          <p:nvPr/>
+        </p:nvSpPr>
+        <p:spPr>
+          <a:xfrm>
+            <a:off x="4846320" y="1005840"/>
+            <a:ext cx="3931920" cy="3840480"/>
           </a:xfrm>
           <a:prstGeom prst="roundRect">
             <a:avLst>
-              <a:gd name="adj" fmla="val 2632"/>
+              <a:gd name="adj" fmla="val 2381"/>
             </a:avLst>
           </a:prstGeom>
           <a:solidFill>
@@ -6438,152 +7447,632 @@
       </p:sp>
       <p:sp>
         <p:nvSpPr>
-          <p:cNvPr id="7" name="Text 5"/>
-          <p:cNvSpPr/>
-          <p:nvPr/>
-        </p:nvSpPr>
-        <p:spPr>
-          <a:xfrm>
-            <a:off x="4937760" y="1188720"/>
-            <a:ext cx="3200400" cy="365760"/>
-          </a:xfrm>
-          <a:prstGeom prst="rect">
-            <a:avLst/>
-          </a:prstGeom>
-          <a:noFill/>
-          <a:ln/>
-        </p:spPr>
-        <p:txBody>
-          <a:bodyPr wrap="square" lIns="0" tIns="0" rIns="0" bIns="0" rtlCol="0" anchor="ctr"/>
-          <a:lstStyle/>
-          <a:p>
-            <a:pPr indent="0" marL="0">
-              <a:buNone/>
-            </a:pPr>
-            <a:r>
-              <a:rPr lang="en-US" sz="1800" b="1" dirty="0">
-                <a:solidFill>
-                  <a:srgbClr val="6C5CE7"/>
-                </a:solidFill>
-                <a:latin typeface="Arial" pitchFamily="34" charset="0"/>
-                <a:ea typeface="Arial" pitchFamily="34" charset="-122"/>
-                <a:cs typeface="Arial" pitchFamily="34" charset="-120"/>
-              </a:rPr>
-              <a:t>Prediction Page</a:t>
-            </a:r>
-            <a:endParaRPr lang="en-US" sz="1800" dirty="0"/>
-          </a:p>
-        </p:txBody>
-      </p:sp>
-      <p:sp>
-        <p:nvSpPr>
-          <p:cNvPr id="8" name="Text 6"/>
-          <p:cNvSpPr/>
-          <p:nvPr/>
-        </p:nvSpPr>
-        <p:spPr>
-          <a:xfrm>
-            <a:off x="4937760" y="1645920"/>
-            <a:ext cx="3566160" cy="2286000"/>
-          </a:xfrm>
-          <a:prstGeom prst="rect">
-            <a:avLst/>
-          </a:prstGeom>
-          <a:noFill/>
-          <a:ln/>
-        </p:spPr>
-        <p:txBody>
-          <a:bodyPr wrap="square" rtlCol="0" anchor="ctr"/>
-          <a:lstStyle/>
-          <a:p>
-            <a:pPr marL="342900" indent="-342900">
-              <a:buSzPct val="100000"/>
-              <a:buChar char="•"/>
-            </a:pPr>
-            <a:r>
-              <a:rPr lang="en-US" sz="1200" dirty="0">
-                <a:solidFill>
-                  <a:srgbClr val="E4E4E7"/>
-                </a:solidFill>
-                <a:latin typeface="Arial" pitchFamily="34" charset="0"/>
-                <a:ea typeface="Arial" pitchFamily="34" charset="-122"/>
-                <a:cs typeface="Arial" pitchFamily="34" charset="-120"/>
-              </a:rPr>
-              <a:t>BUY / SELL with 6-signal reasoning</a:t>
-            </a:r>
-            <a:endParaRPr lang="en-US" sz="1200" dirty="0"/>
-          </a:p>
-          <a:p>
-            <a:pPr marL="342900" indent="-342900">
-              <a:buSzPct val="100000"/>
-              <a:buChar char="•"/>
-            </a:pPr>
-            <a:r>
-              <a:rPr lang="en-US" sz="1200" dirty="0">
-                <a:solidFill>
-                  <a:srgbClr val="E4E4E7"/>
-                </a:solidFill>
-                <a:latin typeface="Arial" pitchFamily="34" charset="0"/>
-                <a:ea typeface="Arial" pitchFamily="34" charset="-122"/>
-                <a:cs typeface="Arial" pitchFamily="34" charset="-120"/>
-              </a:rPr>
-              <a:t>Polymarket table (18 thresholds)</a:t>
-            </a:r>
-            <a:endParaRPr lang="en-US" sz="1200" dirty="0"/>
-          </a:p>
-          <a:p>
-            <a:pPr marL="342900" indent="-342900">
-              <a:buSzPct val="100000"/>
-              <a:buChar char="•"/>
-            </a:pPr>
-            <a:r>
-              <a:rPr lang="en-US" sz="1200" dirty="0">
-                <a:solidFill>
-                  <a:srgbClr val="E4E4E7"/>
-                </a:solidFill>
-                <a:latin typeface="Arial" pitchFamily="34" charset="0"/>
-                <a:ea typeface="Arial" pitchFamily="34" charset="-122"/>
-                <a:cs typeface="Arial" pitchFamily="34" charset="-120"/>
-              </a:rPr>
-              <a:t>Binance order flow visualization</a:t>
-            </a:r>
-            <a:endParaRPr lang="en-US" sz="1200" dirty="0"/>
-          </a:p>
-          <a:p>
-            <a:pPr marL="342900" indent="-342900">
-              <a:buSzPct val="100000"/>
-              <a:buChar char="•"/>
-            </a:pPr>
-            <a:r>
-              <a:rPr lang="en-US" sz="1200" dirty="0">
-                <a:solidFill>
-                  <a:srgbClr val="E4E4E7"/>
-                </a:solidFill>
-                <a:latin typeface="Arial" pitchFamily="34" charset="0"/>
-                <a:ea typeface="Arial" pitchFamily="34" charset="-122"/>
-                <a:cs typeface="Arial" pitchFamily="34" charset="-120"/>
-              </a:rPr>
-              <a:t>RSI, MACD, Bollinger live</a:t>
-            </a:r>
-            <a:endParaRPr lang="en-US" sz="1200" dirty="0"/>
-          </a:p>
-          <a:p>
-            <a:pPr marL="342900" indent="-342900">
-              <a:buSzPct val="100000"/>
-              <a:buChar char="•"/>
-            </a:pPr>
-            <a:r>
-              <a:rPr lang="en-US" sz="1200" dirty="0">
-                <a:solidFill>
-                  <a:srgbClr val="E4E4E7"/>
-                </a:solidFill>
-                <a:latin typeface="Arial" pitchFamily="34" charset="0"/>
-                <a:ea typeface="Arial" pitchFamily="34" charset="-122"/>
-                <a:cs typeface="Arial" pitchFamily="34" charset="-120"/>
-              </a:rPr>
-              <a:t>Portfolio + order management</a:t>
-            </a:r>
-            <a:endParaRPr lang="en-US" sz="1200" dirty="0"/>
+          <p:cNvPr id="18" name="Text 16"/>
+          <p:cNvSpPr/>
+          <p:nvPr/>
+        </p:nvSpPr>
+        <p:spPr>
+          <a:xfrm>
+            <a:off x="5029200" y="1097280"/>
+            <a:ext cx="3200400" cy="320040"/>
+          </a:xfrm>
+          <a:prstGeom prst="rect">
+            <a:avLst/>
+          </a:prstGeom>
+          <a:noFill/>
+          <a:ln/>
+        </p:spPr>
+        <p:txBody>
+          <a:bodyPr wrap="square" lIns="0" tIns="0" rIns="0" bIns="0" rtlCol="0" anchor="ctr"/>
+          <a:lstStyle/>
+          <a:p>
+            <a:pPr indent="0" marL="0">
+              <a:buNone/>
+            </a:pPr>
+            <a:r>
+              <a:rPr lang="en-US" sz="1600" b="1" dirty="0">
+                <a:solidFill>
+                  <a:srgbClr val="FFD93D"/>
+                </a:solidFill>
+                <a:latin typeface="Arial" pitchFamily="34" charset="0"/>
+                <a:ea typeface="Arial" pitchFamily="34" charset="-122"/>
+                <a:cs typeface="Arial" pitchFamily="34" charset="-120"/>
+              </a:rPr>
+              <a:t>The Data Gap</a:t>
+            </a:r>
+            <a:endParaRPr lang="en-US" sz="1600" dirty="0"/>
+          </a:p>
+        </p:txBody>
+      </p:sp>
+      <p:sp>
+        <p:nvSpPr>
+          <p:cNvPr id="19" name="Text 17"/>
+          <p:cNvSpPr/>
+          <p:nvPr/>
+        </p:nvSpPr>
+        <p:spPr>
+          <a:xfrm>
+            <a:off x="5029200" y="1554480"/>
+            <a:ext cx="1371600" cy="228600"/>
+          </a:xfrm>
+          <a:prstGeom prst="rect">
+            <a:avLst/>
+          </a:prstGeom>
+          <a:noFill/>
+          <a:ln/>
+        </p:spPr>
+        <p:txBody>
+          <a:bodyPr wrap="square" lIns="0" tIns="0" rIns="0" bIns="0" rtlCol="0" anchor="ctr"/>
+          <a:lstStyle/>
+          <a:p>
+            <a:pPr indent="0" marL="0">
+              <a:buNone/>
+            </a:pPr>
+            <a:r>
+              <a:rPr lang="en-US" sz="1100" b="1" dirty="0">
+                <a:solidFill>
+                  <a:srgbClr val="71717A"/>
+                </a:solidFill>
+                <a:latin typeface="Arial" pitchFamily="34" charset="0"/>
+                <a:ea typeface="Arial" pitchFamily="34" charset="-122"/>
+                <a:cs typeface="Arial" pitchFamily="34" charset="-120"/>
+              </a:rPr>
+              <a:t>Current</a:t>
+            </a:r>
+            <a:endParaRPr lang="en-US" sz="1100" dirty="0"/>
+          </a:p>
+        </p:txBody>
+      </p:sp>
+      <p:sp>
+        <p:nvSpPr>
+          <p:cNvPr id="20" name="Text 18"/>
+          <p:cNvSpPr/>
+          <p:nvPr/>
+        </p:nvSpPr>
+        <p:spPr>
+          <a:xfrm>
+            <a:off x="6858000" y="1554480"/>
+            <a:ext cx="1645920" cy="228600"/>
+          </a:xfrm>
+          <a:prstGeom prst="rect">
+            <a:avLst/>
+          </a:prstGeom>
+          <a:noFill/>
+          <a:ln/>
+        </p:spPr>
+        <p:txBody>
+          <a:bodyPr wrap="square" lIns="0" tIns="0" rIns="0" bIns="0" rtlCol="0" anchor="ctr"/>
+          <a:lstStyle/>
+          <a:p>
+            <a:pPr algn="r" indent="0" marL="0">
+              <a:buNone/>
+            </a:pPr>
+            <a:r>
+              <a:rPr lang="en-US" sz="1400" b="1" dirty="0">
+                <a:solidFill>
+                  <a:srgbClr val="00D4AA"/>
+                </a:solidFill>
+                <a:latin typeface="Arial" pitchFamily="34" charset="0"/>
+                <a:ea typeface="Arial" pitchFamily="34" charset="-122"/>
+                <a:cs typeface="Arial" pitchFamily="34" charset="-120"/>
+              </a:rPr>
+              <a:t>67.4%</a:t>
+            </a:r>
+            <a:endParaRPr lang="en-US" sz="1400" dirty="0"/>
+          </a:p>
+        </p:txBody>
+      </p:sp>
+      <p:sp>
+        <p:nvSpPr>
+          <p:cNvPr id="21" name="Text 19"/>
+          <p:cNvSpPr/>
+          <p:nvPr/>
+        </p:nvSpPr>
+        <p:spPr>
+          <a:xfrm>
+            <a:off x="5029200" y="1783080"/>
+            <a:ext cx="3657600" cy="182880"/>
+          </a:xfrm>
+          <a:prstGeom prst="rect">
+            <a:avLst/>
+          </a:prstGeom>
+          <a:noFill/>
+          <a:ln/>
+        </p:spPr>
+        <p:txBody>
+          <a:bodyPr wrap="square" lIns="0" tIns="0" rIns="0" bIns="0" rtlCol="0" anchor="ctr"/>
+          <a:lstStyle/>
+          <a:p>
+            <a:pPr indent="0" marL="0">
+              <a:buNone/>
+            </a:pPr>
+            <a:r>
+              <a:rPr lang="en-US" sz="1000" dirty="0">
+                <a:solidFill>
+                  <a:srgbClr val="71717A"/>
+                </a:solidFill>
+                <a:latin typeface="Arial" pitchFamily="34" charset="0"/>
+                <a:ea typeface="Arial" pitchFamily="34" charset="-122"/>
+                <a:cs typeface="Arial" pitchFamily="34" charset="-120"/>
+              </a:rPr>
+              <a:t>42 features from BGeometrics</a:t>
+            </a:r>
+            <a:endParaRPr lang="en-US" sz="1000" dirty="0"/>
+          </a:p>
+        </p:txBody>
+      </p:sp>
+      <p:sp>
+        <p:nvSpPr>
+          <p:cNvPr id="22" name="Shape 20"/>
+          <p:cNvSpPr/>
+          <p:nvPr/>
+        </p:nvSpPr>
+        <p:spPr>
+          <a:xfrm>
+            <a:off x="5029200" y="2103120"/>
+            <a:ext cx="3474720" cy="0"/>
+          </a:xfrm>
+          <a:prstGeom prst="line">
+            <a:avLst/>
+          </a:prstGeom>
+          <a:noFill/>
+          <a:ln w="12700">
+            <a:solidFill>
+              <a:srgbClr val="1E1E2E"/>
+            </a:solidFill>
+            <a:prstDash val="solid"/>
+          </a:ln>
+        </p:spPr>
+      </p:sp>
+      <p:sp>
+        <p:nvSpPr>
+          <p:cNvPr id="23" name="Text 21"/>
+          <p:cNvSpPr/>
+          <p:nvPr/>
+        </p:nvSpPr>
+        <p:spPr>
+          <a:xfrm>
+            <a:off x="5029200" y="2286000"/>
+            <a:ext cx="1371600" cy="228600"/>
+          </a:xfrm>
+          <a:prstGeom prst="rect">
+            <a:avLst/>
+          </a:prstGeom>
+          <a:noFill/>
+          <a:ln/>
+        </p:spPr>
+        <p:txBody>
+          <a:bodyPr wrap="square" lIns="0" tIns="0" rIns="0" bIns="0" rtlCol="0" anchor="ctr"/>
+          <a:lstStyle/>
+          <a:p>
+            <a:pPr indent="0" marL="0">
+              <a:buNone/>
+            </a:pPr>
+            <a:r>
+              <a:rPr lang="en-US" sz="1100" b="1" dirty="0">
+                <a:solidFill>
+                  <a:srgbClr val="71717A"/>
+                </a:solidFill>
+                <a:latin typeface="Arial" pitchFamily="34" charset="0"/>
+                <a:ea typeface="Arial" pitchFamily="34" charset="-122"/>
+                <a:cs typeface="Arial" pitchFamily="34" charset="-120"/>
+              </a:rPr>
+              <a:t>Target</a:t>
+            </a:r>
+            <a:endParaRPr lang="en-US" sz="1100" dirty="0"/>
+          </a:p>
+        </p:txBody>
+      </p:sp>
+      <p:sp>
+        <p:nvSpPr>
+          <p:cNvPr id="24" name="Text 22"/>
+          <p:cNvSpPr/>
+          <p:nvPr/>
+        </p:nvSpPr>
+        <p:spPr>
+          <a:xfrm>
+            <a:off x="6858000" y="2286000"/>
+            <a:ext cx="1645920" cy="228600"/>
+          </a:xfrm>
+          <a:prstGeom prst="rect">
+            <a:avLst/>
+          </a:prstGeom>
+          <a:noFill/>
+          <a:ln/>
+        </p:spPr>
+        <p:txBody>
+          <a:bodyPr wrap="square" lIns="0" tIns="0" rIns="0" bIns="0" rtlCol="0" anchor="ctr"/>
+          <a:lstStyle/>
+          <a:p>
+            <a:pPr algn="r" indent="0" marL="0">
+              <a:buNone/>
+            </a:pPr>
+            <a:r>
+              <a:rPr lang="en-US" sz="1400" b="1" dirty="0">
+                <a:solidFill>
+                  <a:srgbClr val="FFD93D"/>
+                </a:solidFill>
+                <a:latin typeface="Arial" pitchFamily="34" charset="0"/>
+                <a:ea typeface="Arial" pitchFamily="34" charset="-122"/>
+                <a:cs typeface="Arial" pitchFamily="34" charset="-120"/>
+              </a:rPr>
+              <a:t>82.4%</a:t>
+            </a:r>
+            <a:endParaRPr lang="en-US" sz="1400" dirty="0"/>
+          </a:p>
+        </p:txBody>
+      </p:sp>
+      <p:sp>
+        <p:nvSpPr>
+          <p:cNvPr id="25" name="Text 23"/>
+          <p:cNvSpPr/>
+          <p:nvPr/>
+        </p:nvSpPr>
+        <p:spPr>
+          <a:xfrm>
+            <a:off x="5029200" y="2514600"/>
+            <a:ext cx="3657600" cy="182880"/>
+          </a:xfrm>
+          <a:prstGeom prst="rect">
+            <a:avLst/>
+          </a:prstGeom>
+          <a:noFill/>
+          <a:ln/>
+        </p:spPr>
+        <p:txBody>
+          <a:bodyPr wrap="square" lIns="0" tIns="0" rIns="0" bIns="0" rtlCol="0" anchor="ctr"/>
+          <a:lstStyle/>
+          <a:p>
+            <a:pPr indent="0" marL="0">
+              <a:buNone/>
+            </a:pPr>
+            <a:r>
+              <a:rPr lang="en-US" sz="1000" dirty="0">
+                <a:solidFill>
+                  <a:srgbClr val="71717A"/>
+                </a:solidFill>
+                <a:latin typeface="Arial" pitchFamily="34" charset="0"/>
+                <a:ea typeface="Arial" pitchFamily="34" charset="-122"/>
+                <a:cs typeface="Arial" pitchFamily="34" charset="-120"/>
+              </a:rPr>
+              <a:t>87 features from Glassnode Pro ($799/mo)</a:t>
+            </a:r>
+            <a:endParaRPr lang="en-US" sz="1000" dirty="0"/>
+          </a:p>
+        </p:txBody>
+      </p:sp>
+      <p:sp>
+        <p:nvSpPr>
+          <p:cNvPr id="26" name="Shape 24"/>
+          <p:cNvSpPr/>
+          <p:nvPr/>
+        </p:nvSpPr>
+        <p:spPr>
+          <a:xfrm>
+            <a:off x="5029200" y="2834640"/>
+            <a:ext cx="3474720" cy="0"/>
+          </a:xfrm>
+          <a:prstGeom prst="line">
+            <a:avLst/>
+          </a:prstGeom>
+          <a:noFill/>
+          <a:ln w="12700">
+            <a:solidFill>
+              <a:srgbClr val="1E1E2E"/>
+            </a:solidFill>
+            <a:prstDash val="solid"/>
+          </a:ln>
+        </p:spPr>
+      </p:sp>
+      <p:sp>
+        <p:nvSpPr>
+          <p:cNvPr id="27" name="Text 25"/>
+          <p:cNvSpPr/>
+          <p:nvPr/>
+        </p:nvSpPr>
+        <p:spPr>
+          <a:xfrm>
+            <a:off x="5029200" y="3017520"/>
+            <a:ext cx="3657600" cy="228600"/>
+          </a:xfrm>
+          <a:prstGeom prst="rect">
+            <a:avLst/>
+          </a:prstGeom>
+          <a:noFill/>
+          <a:ln/>
+        </p:spPr>
+        <p:txBody>
+          <a:bodyPr wrap="square" lIns="0" tIns="0" rIns="0" bIns="0" rtlCol="0" anchor="ctr"/>
+          <a:lstStyle/>
+          <a:p>
+            <a:pPr indent="0" marL="0">
+              <a:buNone/>
+            </a:pPr>
+            <a:r>
+              <a:rPr lang="en-US" sz="1100" b="1" dirty="0">
+                <a:solidFill>
+                  <a:srgbClr val="FFFFFF"/>
+                </a:solidFill>
+                <a:latin typeface="Arial" pitchFamily="34" charset="0"/>
+                <a:ea typeface="Arial" pitchFamily="34" charset="-122"/>
+                <a:cs typeface="Arial" pitchFamily="34" charset="-120"/>
+              </a:rPr>
+              <a:t>What’s missing:</a:t>
+            </a:r>
+            <a:endParaRPr lang="en-US" sz="1100" dirty="0"/>
+          </a:p>
+        </p:txBody>
+      </p:sp>
+      <p:sp>
+        <p:nvSpPr>
+          <p:cNvPr id="28" name="Text 26"/>
+          <p:cNvSpPr/>
+          <p:nvPr/>
+        </p:nvSpPr>
+        <p:spPr>
+          <a:xfrm>
+            <a:off x="5212080" y="3291840"/>
+            <a:ext cx="3474720" cy="201168"/>
+          </a:xfrm>
+          <a:prstGeom prst="rect">
+            <a:avLst/>
+          </a:prstGeom>
+          <a:noFill/>
+          <a:ln/>
+        </p:spPr>
+        <p:txBody>
+          <a:bodyPr wrap="square" lIns="0" tIns="0" rIns="0" bIns="0" rtlCol="0" anchor="ctr"/>
+          <a:lstStyle/>
+          <a:p>
+            <a:pPr indent="0" marL="0">
+              <a:buNone/>
+            </a:pPr>
+            <a:r>
+              <a:rPr lang="en-US" sz="900" dirty="0">
+                <a:solidFill>
+                  <a:srgbClr val="71717A"/>
+                </a:solidFill>
+                <a:latin typeface="Arial" pitchFamily="34" charset="0"/>
+                <a:ea typeface="Arial" pitchFamily="34" charset="-122"/>
+                <a:cs typeface="Arial" pitchFamily="34" charset="-120"/>
+              </a:rPr>
+              <a:t>• HODL waves (all 15 age bands vs our 13)</a:t>
+            </a:r>
+            <a:endParaRPr lang="en-US" sz="900" dirty="0"/>
+          </a:p>
+        </p:txBody>
+      </p:sp>
+      <p:sp>
+        <p:nvSpPr>
+          <p:cNvPr id="29" name="Text 27"/>
+          <p:cNvSpPr/>
+          <p:nvPr/>
+        </p:nvSpPr>
+        <p:spPr>
+          <a:xfrm>
+            <a:off x="5212080" y="3520440"/>
+            <a:ext cx="3474720" cy="201168"/>
+          </a:xfrm>
+          <a:prstGeom prst="rect">
+            <a:avLst/>
+          </a:prstGeom>
+          <a:noFill/>
+          <a:ln/>
+        </p:spPr>
+        <p:txBody>
+          <a:bodyPr wrap="square" lIns="0" tIns="0" rIns="0" bIns="0" rtlCol="0" anchor="ctr"/>
+          <a:lstStyle/>
+          <a:p>
+            <a:pPr indent="0" marL="0">
+              <a:buNone/>
+            </a:pPr>
+            <a:r>
+              <a:rPr lang="en-US" sz="900" dirty="0">
+                <a:solidFill>
+                  <a:srgbClr val="71717A"/>
+                </a:solidFill>
+                <a:latin typeface="Arial" pitchFamily="34" charset="0"/>
+                <a:ea typeface="Arial" pitchFamily="34" charset="-122"/>
+                <a:cs typeface="Arial" pitchFamily="34" charset="-120"/>
+              </a:rPr>
+              <a:t>• Realized cap HODL waves</a:t>
+            </a:r>
+            <a:endParaRPr lang="en-US" sz="900" dirty="0"/>
+          </a:p>
+        </p:txBody>
+      </p:sp>
+      <p:sp>
+        <p:nvSpPr>
+          <p:cNvPr id="30" name="Text 28"/>
+          <p:cNvSpPr/>
+          <p:nvPr/>
+        </p:nvSpPr>
+        <p:spPr>
+          <a:xfrm>
+            <a:off x="5212080" y="3749040"/>
+            <a:ext cx="3474720" cy="201168"/>
+          </a:xfrm>
+          <a:prstGeom prst="rect">
+            <a:avLst/>
+          </a:prstGeom>
+          <a:noFill/>
+          <a:ln/>
+        </p:spPr>
+        <p:txBody>
+          <a:bodyPr wrap="square" lIns="0" tIns="0" rIns="0" bIns="0" rtlCol="0" anchor="ctr"/>
+          <a:lstStyle/>
+          <a:p>
+            <a:pPr indent="0" marL="0">
+              <a:buNone/>
+            </a:pPr>
+            <a:r>
+              <a:rPr lang="en-US" sz="900" dirty="0">
+                <a:solidFill>
+                  <a:srgbClr val="71717A"/>
+                </a:solidFill>
+                <a:latin typeface="Arial" pitchFamily="34" charset="0"/>
+                <a:ea typeface="Arial" pitchFamily="34" charset="-122"/>
+                <a:cs typeface="Arial" pitchFamily="34" charset="-120"/>
+              </a:rPr>
+              <a:t>• Entity-adjusted dormancy flow</a:t>
+            </a:r>
+            <a:endParaRPr lang="en-US" sz="900" dirty="0"/>
+          </a:p>
+        </p:txBody>
+      </p:sp>
+      <p:sp>
+        <p:nvSpPr>
+          <p:cNvPr id="31" name="Text 29"/>
+          <p:cNvSpPr/>
+          <p:nvPr/>
+        </p:nvSpPr>
+        <p:spPr>
+          <a:xfrm>
+            <a:off x="5212080" y="3977640"/>
+            <a:ext cx="3474720" cy="201168"/>
+          </a:xfrm>
+          <a:prstGeom prst="rect">
+            <a:avLst/>
+          </a:prstGeom>
+          <a:noFill/>
+          <a:ln/>
+        </p:spPr>
+        <p:txBody>
+          <a:bodyPr wrap="square" lIns="0" tIns="0" rIns="0" bIns="0" rtlCol="0" anchor="ctr"/>
+          <a:lstStyle/>
+          <a:p>
+            <a:pPr indent="0" marL="0">
+              <a:buNone/>
+            </a:pPr>
+            <a:r>
+              <a:rPr lang="en-US" sz="900" dirty="0">
+                <a:solidFill>
+                  <a:srgbClr val="71717A"/>
+                </a:solidFill>
+                <a:latin typeface="Arial" pitchFamily="34" charset="0"/>
+                <a:ea typeface="Arial" pitchFamily="34" charset="-122"/>
+                <a:cs typeface="Arial" pitchFamily="34" charset="-120"/>
+              </a:rPr>
+              <a:t>• Stock-to-flow ratio</a:t>
+            </a:r>
+            <a:endParaRPr lang="en-US" sz="900" dirty="0"/>
+          </a:p>
+        </p:txBody>
+      </p:sp>
+      <p:sp>
+        <p:nvSpPr>
+          <p:cNvPr id="32" name="Text 30"/>
+          <p:cNvSpPr/>
+          <p:nvPr/>
+        </p:nvSpPr>
+        <p:spPr>
+          <a:xfrm>
+            <a:off x="5212080" y="4206240"/>
+            <a:ext cx="3474720" cy="201168"/>
+          </a:xfrm>
+          <a:prstGeom prst="rect">
+            <a:avLst/>
+          </a:prstGeom>
+          <a:noFill/>
+          <a:ln/>
+        </p:spPr>
+        <p:txBody>
+          <a:bodyPr wrap="square" lIns="0" tIns="0" rIns="0" bIns="0" rtlCol="0" anchor="ctr"/>
+          <a:lstStyle/>
+          <a:p>
+            <a:pPr indent="0" marL="0">
+              <a:buNone/>
+            </a:pPr>
+            <a:r>
+              <a:rPr lang="en-US" sz="900" dirty="0">
+                <a:solidFill>
+                  <a:srgbClr val="71717A"/>
+                </a:solidFill>
+                <a:latin typeface="Arial" pitchFamily="34" charset="0"/>
+                <a:ea typeface="Arial" pitchFamily="34" charset="-122"/>
+                <a:cs typeface="Arial" pitchFamily="34" charset="-120"/>
+              </a:rPr>
+              <a:t>• Difficulty ribbon compression</a:t>
+            </a:r>
+            <a:endParaRPr lang="en-US" sz="900" dirty="0"/>
+          </a:p>
+        </p:txBody>
+      </p:sp>
+      <p:sp>
+        <p:nvSpPr>
+          <p:cNvPr id="33" name="Text 31"/>
+          <p:cNvSpPr/>
+          <p:nvPr/>
+        </p:nvSpPr>
+        <p:spPr>
+          <a:xfrm>
+            <a:off x="5212080" y="4434840"/>
+            <a:ext cx="3474720" cy="201168"/>
+          </a:xfrm>
+          <a:prstGeom prst="rect">
+            <a:avLst/>
+          </a:prstGeom>
+          <a:noFill/>
+          <a:ln/>
+        </p:spPr>
+        <p:txBody>
+          <a:bodyPr wrap="square" lIns="0" tIns="0" rIns="0" bIns="0" rtlCol="0" anchor="ctr"/>
+          <a:lstStyle/>
+          <a:p>
+            <a:pPr indent="0" marL="0">
+              <a:buNone/>
+            </a:pPr>
+            <a:r>
+              <a:rPr lang="en-US" sz="900" dirty="0">
+                <a:solidFill>
+                  <a:srgbClr val="71717A"/>
+                </a:solidFill>
+                <a:latin typeface="Arial" pitchFamily="34" charset="0"/>
+                <a:ea typeface="Arial" pitchFamily="34" charset="-122"/>
+                <a:cs typeface="Arial" pitchFamily="34" charset="-120"/>
+              </a:rPr>
+              <a:t>• 45 additional on-chain indicators</a:t>
+            </a:r>
+            <a:endParaRPr lang="en-US" sz="900" dirty="0"/>
+          </a:p>
+        </p:txBody>
+      </p:sp>
+      <p:sp>
+        <p:nvSpPr>
+          <p:cNvPr id="34" name="Text 32"/>
+          <p:cNvSpPr/>
+          <p:nvPr/>
+        </p:nvSpPr>
+        <p:spPr>
+          <a:xfrm>
+            <a:off x="5029200" y="4572000"/>
+            <a:ext cx="3474720" cy="182880"/>
+          </a:xfrm>
+          <a:prstGeom prst="rect">
+            <a:avLst/>
+          </a:prstGeom>
+          <a:noFill/>
+          <a:ln/>
+        </p:spPr>
+        <p:txBody>
+          <a:bodyPr wrap="square" lIns="0" tIns="0" rIns="0" bIns="0" rtlCol="0" anchor="ctr"/>
+          <a:lstStyle/>
+          <a:p>
+            <a:pPr indent="0" marL="0">
+              <a:buNone/>
+            </a:pPr>
+            <a:r>
+              <a:rPr lang="en-US" sz="900" i="1" dirty="0">
+                <a:solidFill>
+                  <a:srgbClr val="FFD93D"/>
+                </a:solidFill>
+                <a:latin typeface="Arial" pitchFamily="34" charset="0"/>
+                <a:ea typeface="Arial" pitchFamily="34" charset="-122"/>
+                <a:cs typeface="Arial" pitchFamily="34" charset="-120"/>
+              </a:rPr>
+              <a:t>More data is the single biggest lever to improve accuracy.</a:t>
+            </a:r>
+            <a:endParaRPr lang="en-US" sz="900" dirty="0"/>
           </a:p>
         </p:txBody>
       </p:sp>

</xml_diff>